<commit_message>
docs: viết rõ ràng hơn nội dung slide, bỏ viết tắt cụt lủn
Sửa các chỗ đọc như nhãn cụt (UI, dấu &, "sinh code") thành cụm từ
đầy đủ, tường minh: "thiết kế giao diện", "viết code tự động",
"brainstorm ý tưởng", "hoàn thiện sản phẩm", "đọc và đánh giá kết
quả". Việt hóa "live-build" và "core loop" ở slide 1 và 5.
</commit_message>
<xml_diff>
--- a/docs/superpowers/slides/vibe-coding-workshop-buoi1-slides.pptx
+++ b/docs/superpowers/slides/vibe-coding-workshop-buoi1-slides.pptx
@@ -1365,7 +1365,7 @@
                 <a:ea typeface="Calibri" pitchFamily="34" charset="-122"/>
                 <a:cs typeface="Calibri" pitchFamily="34" charset="-120"/>
               </a:rPr>
-              <a:t>Buổi 1 — Live-build một app thật, từ số 0, cùng AI</a:t>
+              <a:t>Buổi 1 — Xây dựng trực tiếp một ứng dụng thật, từ con số 0, cùng AI</a:t>
             </a:r>
             <a:endParaRPr lang="en-US" sz="1800" dirty="0"/>
           </a:p>
@@ -2395,7 +2395,7 @@
                 <a:ea typeface="Cambria" pitchFamily="34" charset="-122"/>
                 <a:cs typeface="Cambria" pitchFamily="34" charset="-120"/>
               </a:rPr>
-              <a:t>Đọc &amp; review kết quả</a:t>
+              <a:t>Đọc và đánh giá kết quả</a:t>
             </a:r>
             <a:endParaRPr lang="en-US" sz="1700" dirty="0"/>
           </a:p>
@@ -2901,7 +2901,7 @@
                 <a:ea typeface="Calibri" pitchFamily="34" charset="-122"/>
                 <a:cs typeface="Calibri" pitchFamily="34" charset="-120"/>
               </a:rPr>
-              <a:t>Brainstorm</a:t>
+              <a:t>Brainstorm ý tưởng</a:t>
             </a:r>
             <a:endParaRPr lang="en-US" sz="1300" dirty="0"/>
           </a:p>
@@ -3089,7 +3089,7 @@
                 <a:ea typeface="Calibri" pitchFamily="34" charset="-122"/>
                 <a:cs typeface="Calibri" pitchFamily="34" charset="-120"/>
               </a:rPr>
-              <a:t>Thiết kế UI</a:t>
+              <a:t>Thiết kế giao diện</a:t>
             </a:r>
             <a:endParaRPr lang="en-US" sz="1300" dirty="0"/>
           </a:p>
@@ -3235,7 +3235,7 @@
                 <a:ea typeface="Calibri" pitchFamily="34" charset="-122"/>
                 <a:cs typeface="Calibri" pitchFamily="34" charset="-120"/>
               </a:rPr>
-              <a:t>Sinh code</a:t>
+              <a:t>Viết code tự động</a:t>
             </a:r>
             <a:endParaRPr lang="en-US" sz="1300" dirty="0"/>
           </a:p>
@@ -3381,7 +3381,7 @@
                 <a:ea typeface="Calibri" pitchFamily="34" charset="-122"/>
                 <a:cs typeface="Calibri" pitchFamily="34" charset="-120"/>
               </a:rPr>
-              <a:t>Hoàn thiện</a:t>
+              <a:t>Hoàn thiện sản phẩm</a:t>
             </a:r>
             <a:endParaRPr lang="en-US" sz="1300" dirty="0"/>
           </a:p>
@@ -3786,7 +3786,7 @@
                 <a:ea typeface="Cambria" pitchFamily="34" charset="-122"/>
                 <a:cs typeface="Cambria" pitchFamily="34" charset="-120"/>
               </a:rPr>
-              <a:t>để dựng LÕI (core loop) của một app thật đang chạy</a:t>
+              <a:t>để dựng phần LÕI — vòng lặp chơi cốt lõi — của một ứng dụng thật đang chạy</a:t>
             </a:r>
             <a:endParaRPr lang="en-US" sz="2400" dirty="0"/>
           </a:p>
@@ -3990,8 +3990,8 @@
         </p:nvSpPr>
         <p:spPr>
           <a:xfrm>
-            <a:off x="5852160" y="5669280"/>
-            <a:ext cx="2743200" cy="548640"/>
+            <a:off x="4572000" y="5669280"/>
+            <a:ext cx="4023360" cy="548640"/>
           </a:xfrm>
           <a:prstGeom prst="rect">
             <a:avLst/>
@@ -4015,7 +4015,7 @@
                 <a:ea typeface="Cambria" pitchFamily="34" charset="-122"/>
                 <a:cs typeface="Cambria" pitchFamily="34" charset="-120"/>
               </a:rPr>
-              <a:t>Bắt đầu build live</a:t>
+              <a:t>Bắt đầu xây dựng trực tiếp</a:t>
             </a:r>
             <a:endParaRPr lang="en-US" sz="1800" dirty="0"/>
           </a:p>

</xml_diff>

<commit_message>
docs: chỉnh sửa slide mở đầu workshop (rút gọn nhãn mục lặp lại)
Cập nhật từ bản chỉnh tay trong PowerPoint sau bản Claude Code sinh.
</commit_message>
<xml_diff>
--- a/docs/superpowers/slides/vibe-coding-workshop-buoi1-slides.pptx
+++ b/docs/superpowers/slides/vibe-coding-workshop-buoi1-slides.pptx
@@ -4,6 +4,9 @@
   <p:sldMasterIdLst>
     <p:sldMasterId id="2147483648" r:id="rId1"/>
   </p:sldMasterIdLst>
+  <p:notesMasterIdLst>
+    <p:notesMasterId r:id="rId7"/>
+  </p:notesMasterIdLst>
   <p:sldIdLst>
     <p:sldId id="256" r:id="rId2"/>
     <p:sldId id="257" r:id="rId3"/>
@@ -11,9 +14,6 @@
     <p:sldId id="259" r:id="rId5"/>
     <p:sldId id="260" r:id="rId6"/>
   </p:sldIdLst>
-  <p:notesMasterIdLst>
-    <p:notesMasterId r:id="rId7"/>
-  </p:notesMasterIdLst>
   <p:sldSz cx="12192000" cy="6858000"/>
   <p:notesSz cx="6858000" cy="12192000"/>
   <p:defaultTextStyle>
@@ -108,6 +108,11 @@
       </a:defRPr>
     </a:lvl9pPr>
   </p:defaultTextStyle>
+  <p:extLst>
+    <p:ext uri="{EFAFB233-063F-42B5-8137-9DF3F51BA10A}">
+      <p15:sldGuideLst xmlns:p15="http://schemas.microsoft.com/office/powerpoint/2012/main"/>
+    </p:ext>
+  </p:extLst>
 </p:presentation>
 </file>
 
@@ -133,234 +138,10 @@
           <a:chExt cx="0" cy="0"/>
         </a:xfrm>
       </p:grpSpPr>
-      <p:sp>
-        <p:nvSpPr>
-          <p:cNvPr id="2" name="Header Placeholder 1"/>
-          <p:cNvSpPr>
-            <a:spLocks noGrp="1"/>
-          </p:cNvSpPr>
-          <p:nvPr>
-            <p:ph type="hdr" sz="quarter"/>
-          </p:nvPr>
-        </p:nvSpPr>
-        <p:spPr>
-          <a:xfrm>
-            <a:off x="0" y="0"/>
-            <a:ext cx="2971800" cy="458788"/>
-          </a:xfrm>
-          <a:prstGeom prst="rect">
-            <a:avLst/>
-          </a:prstGeom>
-        </p:spPr>
-        <p:txBody>
-          <a:bodyPr vert="horz" lIns="91440" tIns="45720" rIns="91440" bIns="45720" rtlCol="0"/>
-          <a:lstStyle>
-            <a:lvl1pPr algn="l">
-              <a:defRPr sz="1200"/>
-            </a:lvl1pPr>
-          </a:lstStyle>
-          <a:p>
-            <a:endParaRPr lang="en-US"/>
-          </a:p>
-        </p:txBody>
-      </p:sp>
-      <p:sp>
-        <p:nvSpPr>
-          <p:cNvPr id="3" name="Date Placeholder 2"/>
-          <p:cNvSpPr>
-            <a:spLocks noGrp="1"/>
-          </p:cNvSpPr>
-          <p:nvPr>
-            <p:ph type="dt" idx="1"/>
-          </p:nvPr>
-        </p:nvSpPr>
-        <p:spPr>
-          <a:xfrm>
-            <a:off x="3884613" y="0"/>
-            <a:ext cx="2971800" cy="458788"/>
-          </a:xfrm>
-          <a:prstGeom prst="rect">
-            <a:avLst/>
-          </a:prstGeom>
-        </p:spPr>
-        <p:txBody>
-          <a:bodyPr vert="horz" lIns="91440" tIns="45720" rIns="91440" bIns="45720" rtlCol="0"/>
-          <a:lstStyle>
-            <a:lvl1pPr algn="r">
-              <a:defRPr sz="1200"/>
-            </a:lvl1pPr>
-          </a:lstStyle>
-          <a:p>
-            <a:fld id="{5282F153-3F37-0F45-9E97-73ACFA13230C}" type="datetimeFigureOut">
-              <a:rPr lang="en-US"/>
-              <a:t>7/23/19</a:t>
-            </a:fld>
-            <a:endParaRPr lang="en-US"/>
-          </a:p>
-        </p:txBody>
-      </p:sp>
-      <p:sp>
-        <p:nvSpPr>
-          <p:cNvPr id="4" name="Slide Image Placeholder 3"/>
-          <p:cNvSpPr>
-            <a:spLocks noGrp="1" noRot="1" noChangeAspect="1"/>
-          </p:cNvSpPr>
-          <p:nvPr>
-            <p:ph type="sldImg" idx="2"/>
-          </p:nvPr>
-        </p:nvSpPr>
-        <p:spPr>
-          <a:xfrm>
-            <a:off x="685800" y="1143000"/>
-            <a:ext cx="5486400" cy="3086100"/>
-          </a:xfrm>
-          <a:prstGeom prst="rect">
-            <a:avLst/>
-          </a:prstGeom>
-          <a:noFill/>
-          <a:ln w="12700">
-            <a:solidFill>
-              <a:prstClr val="black"/>
-            </a:solidFill>
-          </a:ln>
-        </p:spPr>
-        <p:txBody>
-          <a:bodyPr vert="horz" lIns="91440" tIns="45720" rIns="91440" bIns="45720" rtlCol="0" anchor="ctr"/>
-          <a:lstStyle/>
-          <a:p>
-            <a:endParaRPr lang="en-US"/>
-          </a:p>
-        </p:txBody>
-      </p:sp>
-      <p:sp>
-        <p:nvSpPr>
-          <p:cNvPr id="5" name="Notes Placeholder 4"/>
-          <p:cNvSpPr>
-            <a:spLocks noGrp="1"/>
-          </p:cNvSpPr>
-          <p:nvPr>
-            <p:ph type="body" sz="quarter" idx="3"/>
-          </p:nvPr>
-        </p:nvSpPr>
-        <p:spPr>
-          <a:xfrm>
-            <a:off x="685800" y="4400550"/>
-            <a:ext cx="5486400" cy="3600450"/>
-          </a:xfrm>
-          <a:prstGeom prst="rect">
-            <a:avLst/>
-          </a:prstGeom>
-        </p:spPr>
-        <p:txBody>
-          <a:bodyPr vert="horz" lIns="91440" tIns="45720" rIns="91440" bIns="45720" rtlCol="0"/>
-          <a:lstStyle/>
-          <a:p>
-            <a:pPr lvl="0"/>
-            <a:r>
-              <a:rPr lang="en-US"/>
-              <a:t>Click to edit Master text styles</a:t>
-            </a:r>
-          </a:p>
-          <a:p>
-            <a:pPr lvl="1"/>
-            <a:r>
-              <a:rPr lang="en-US"/>
-              <a:t>Second level</a:t>
-            </a:r>
-          </a:p>
-          <a:p>
-            <a:pPr lvl="2"/>
-            <a:r>
-              <a:rPr lang="en-US"/>
-              <a:t>Third level</a:t>
-            </a:r>
-          </a:p>
-          <a:p>
-            <a:pPr lvl="3"/>
-            <a:r>
-              <a:rPr lang="en-US"/>
-              <a:t>Fourth level</a:t>
-            </a:r>
-          </a:p>
-          <a:p>
-            <a:pPr lvl="4"/>
-            <a:r>
-              <a:rPr lang="en-US"/>
-              <a:t>Fifth level</a:t>
-            </a:r>
-          </a:p>
-        </p:txBody>
-      </p:sp>
-      <p:sp>
-        <p:nvSpPr>
-          <p:cNvPr id="6" name="Footer Placeholder 5"/>
-          <p:cNvSpPr>
-            <a:spLocks noGrp="1"/>
-          </p:cNvSpPr>
-          <p:nvPr>
-            <p:ph type="ftr" sz="quarter" idx="4"/>
-          </p:nvPr>
-        </p:nvSpPr>
-        <p:spPr>
-          <a:xfrm>
-            <a:off x="0" y="8685213"/>
-            <a:ext cx="2971800" cy="458787"/>
-          </a:xfrm>
-          <a:prstGeom prst="rect">
-            <a:avLst/>
-          </a:prstGeom>
-        </p:spPr>
-        <p:txBody>
-          <a:bodyPr vert="horz" lIns="91440" tIns="45720" rIns="91440" bIns="45720" rtlCol="0" anchor="b"/>
-          <a:lstStyle>
-            <a:lvl1pPr algn="l">
-              <a:defRPr sz="1200"/>
-            </a:lvl1pPr>
-          </a:lstStyle>
-          <a:p>
-            <a:endParaRPr lang="en-US"/>
-          </a:p>
-        </p:txBody>
-      </p:sp>
-      <p:sp>
-        <p:nvSpPr>
-          <p:cNvPr id="7" name="Slide Number Placeholder 6"/>
-          <p:cNvSpPr>
-            <a:spLocks noGrp="1"/>
-          </p:cNvSpPr>
-          <p:nvPr>
-            <p:ph type="sldNum" sz="quarter" idx="5"/>
-          </p:nvPr>
-        </p:nvSpPr>
-        <p:spPr>
-          <a:xfrm>
-            <a:off x="3884613" y="8685213"/>
-            <a:ext cx="2971800" cy="458787"/>
-          </a:xfrm>
-          <a:prstGeom prst="rect">
-            <a:avLst/>
-          </a:prstGeom>
-        </p:spPr>
-        <p:txBody>
-          <a:bodyPr vert="horz" lIns="91440" tIns="45720" rIns="91440" bIns="45720" rtlCol="0" anchor="b"/>
-          <a:lstStyle>
-            <a:lvl1pPr algn="r">
-              <a:defRPr sz="1200"/>
-            </a:lvl1pPr>
-          </a:lstStyle>
-          <a:p>
-            <a:fld id="{CE5E9CC1-C706-0F49-92D6-E571CC5EEA8F}" type="slidenum">
-              <a:rPr lang="en-US"/>
-              <a:t>‹#›</a:t>
-            </a:fld>
-            <a:endParaRPr lang="en-US"/>
-          </a:p>
-        </p:txBody>
-      </p:sp>
     </p:spTree>
     <p:extLst>
       <p:ext uri="{BB962C8B-B14F-4D97-AF65-F5344CB8AC3E}">
-        <p14:creationId xmlns:p14="http://schemas.microsoft.com/office/powerpoint/2010/main" val="1024086991"/>
+        <p14:creationId xmlns:p14="http://schemas.microsoft.com/office/powerpoint/2010/main" val="3715960933"/>
       </p:ext>
     </p:extLst>
   </p:cSld>
@@ -504,10 +285,6 @@
           <a:bodyPr/>
           <a:lstStyle/>
           <a:p>
-            <a:r>
-              <a:rPr lang="en-US" dirty="0"/>
-              <a:t/>
-            </a:r>
             <a:endParaRPr lang="en-US" dirty="0"/>
           </a:p>
         </p:txBody>
@@ -592,10 +369,6 @@
           <a:bodyPr/>
           <a:lstStyle/>
           <a:p>
-            <a:r>
-              <a:rPr lang="en-US" dirty="0"/>
-              <a:t/>
-            </a:r>
             <a:endParaRPr lang="en-US" dirty="0"/>
           </a:p>
         </p:txBody>
@@ -680,10 +453,6 @@
           <a:bodyPr/>
           <a:lstStyle/>
           <a:p>
-            <a:r>
-              <a:rPr lang="en-US" dirty="0"/>
-              <a:t/>
-            </a:r>
             <a:endParaRPr lang="en-US" dirty="0"/>
           </a:p>
         </p:txBody>
@@ -768,10 +537,6 @@
           <a:bodyPr/>
           <a:lstStyle/>
           <a:p>
-            <a:r>
-              <a:rPr lang="en-US" dirty="0"/>
-              <a:t/>
-            </a:r>
             <a:endParaRPr lang="en-US" dirty="0"/>
           </a:p>
         </p:txBody>
@@ -856,10 +621,6 @@
           <a:bodyPr/>
           <a:lstStyle/>
           <a:p>
-            <a:r>
-              <a:rPr lang="en-US" dirty="0"/>
-              <a:t/>
-            </a:r>
             <a:endParaRPr lang="en-US" dirty="0"/>
           </a:p>
         </p:txBody>
@@ -933,6 +694,11 @@
 <file path=ppt/slideMasters/slideMaster1.xml><?xml version="1.0" encoding="utf-8"?>
 <p:sldMaster xmlns:a="http://schemas.openxmlformats.org/drawingml/2006/main" xmlns:r="http://schemas.openxmlformats.org/officeDocument/2006/relationships" xmlns:p="http://schemas.openxmlformats.org/presentationml/2006/main">
   <p:cSld>
+    <p:bg>
+      <p:bgRef idx="1001">
+        <a:schemeClr val="bg1"/>
+      </p:bgRef>
+    </p:bg>
     <p:spTree>
       <p:nvGrpSpPr>
         <p:cNvPr id="1" name=""/>
@@ -1215,6 +981,7 @@
         <a:solidFill>
           <a:srgbClr val="1E2761"/>
         </a:solidFill>
+        <a:effectLst/>
       </p:bgPr>
     </p:bg>
     <p:spTree>
@@ -1252,11 +1019,11 @@
           <a:bodyPr wrap="square" lIns="0" tIns="0" rIns="0" bIns="0" rtlCol="0" anchor="ctr"/>
           <a:lstStyle/>
           <a:p>
-            <a:pPr indent="0" marL="0">
-              <a:buNone/>
-            </a:pPr>
-            <a:r>
-              <a:rPr lang="en-US" sz="1300" b="1" spc="300" kern="0" dirty="0">
+            <a:pPr marL="0" indent="0">
+              <a:buNone/>
+            </a:pPr>
+            <a:r>
+              <a:rPr lang="en-US" sz="1300" b="1" kern="0" spc="300" dirty="0">
                 <a:solidFill>
                   <a:srgbClr val="F96167"/>
                 </a:solidFill>
@@ -1291,7 +1058,7 @@
           <a:bodyPr wrap="square" lIns="0" tIns="0" rIns="0" bIns="0" rtlCol="0" anchor="ctr"/>
           <a:lstStyle/>
           <a:p>
-            <a:pPr indent="0" marL="0">
+            <a:pPr marL="0" indent="0">
               <a:lnSpc>
                 <a:spcPts val="5200"/>
               </a:lnSpc>
@@ -1311,7 +1078,7 @@
             <a:endParaRPr lang="en-US" sz="4800" dirty="0"/>
           </a:p>
           <a:p>
-            <a:pPr indent="0" marL="0">
+            <a:pPr marL="0" indent="0">
               <a:lnSpc>
                 <a:spcPts val="5200"/>
               </a:lnSpc>
@@ -1353,7 +1120,7 @@
           <a:bodyPr wrap="square" lIns="0" tIns="0" rIns="0" bIns="0" rtlCol="0" anchor="ctr"/>
           <a:lstStyle/>
           <a:p>
-            <a:pPr indent="0" marL="0">
+            <a:pPr marL="0" indent="0">
               <a:buNone/>
             </a:pPr>
             <a:r>
@@ -1392,7 +1159,7 @@
           <a:bodyPr wrap="square" lIns="0" tIns="0" rIns="0" bIns="0" rtlCol="0" anchor="ctr"/>
           <a:lstStyle/>
           <a:p>
-            <a:pPr indent="0" marL="0">
+            <a:pPr marL="0" indent="0">
               <a:buNone/>
             </a:pPr>
             <a:r>
@@ -1431,7 +1198,7 @@
           <a:bodyPr wrap="square" lIns="0" tIns="0" rIns="0" bIns="0" rtlCol="0" anchor="ctr"/>
           <a:lstStyle/>
           <a:p>
-            <a:pPr indent="0" marL="0">
+            <a:pPr marL="0" indent="0">
               <a:buNone/>
             </a:pPr>
             <a:r>
@@ -1468,17 +1235,24 @@
           </a:solidFill>
           <a:ln/>
         </p:spPr>
+        <p:txBody>
+          <a:bodyPr/>
+          <a:lstStyle/>
+          <a:p>
+            <a:endParaRPr lang="en-VN"/>
+          </a:p>
+        </p:txBody>
       </p:sp>
       <p:pic>
         <p:nvPicPr>
-          <p:cNvPr id="8" name="Image 0" descr="/private/tmp/claude-501/-Users-wanbi-Code-oss-projects-viettyping/819a7611-2cb6-438f-ae7c-0ad07e99bd3f/scratchpad/slides/icons/rocket_white.png">    </p:cNvPr>
+          <p:cNvPr id="8" name="Image 0" descr="/private/tmp/claude-501/-Users-wanbi-Code-oss-projects-viettyping/819a7611-2cb6-438f-ae7c-0ad07e99bd3f/scratchpad/slides/icons/rocket_white.png"/>
           <p:cNvPicPr>
             <a:picLocks noChangeAspect="1"/>
           </p:cNvPicPr>
           <p:nvPr/>
         </p:nvPicPr>
         <p:blipFill>
-          <a:blip r:embed="rId1"/>
+          <a:blip r:embed="rId3"/>
           <a:stretch>
             <a:fillRect/>
           </a:stretch>
@@ -1509,6 +1283,7 @@
         <a:solidFill>
           <a:srgbClr val="FFFFFF"/>
         </a:solidFill>
+        <a:effectLst/>
       </p:bgPr>
     </p:bg>
     <p:spTree>
@@ -1527,45 +1302,6 @@
       </p:grpSpPr>
       <p:sp>
         <p:nvSpPr>
-          <p:cNvPr id="2" name="Text 0"/>
-          <p:cNvSpPr/>
-          <p:nvPr/>
-        </p:nvSpPr>
-        <p:spPr>
-          <a:xfrm>
-            <a:off x="640080" y="502920"/>
-            <a:ext cx="5486400" cy="320040"/>
-          </a:xfrm>
-          <a:prstGeom prst="rect">
-            <a:avLst/>
-          </a:prstGeom>
-          <a:noFill/>
-          <a:ln/>
-        </p:spPr>
-        <p:txBody>
-          <a:bodyPr wrap="square" lIns="0" tIns="0" rIns="0" bIns="0" rtlCol="0" anchor="ctr"/>
-          <a:lstStyle/>
-          <a:p>
-            <a:pPr indent="0" marL="0">
-              <a:buNone/>
-            </a:pPr>
-            <a:r>
-              <a:rPr lang="en-US" sz="1200" b="1" spc="300" kern="0" dirty="0">
-                <a:solidFill>
-                  <a:srgbClr val="F96167"/>
-                </a:solidFill>
-                <a:latin typeface="Calibri" pitchFamily="34" charset="0"/>
-                <a:ea typeface="Calibri" pitchFamily="34" charset="-122"/>
-                <a:cs typeface="Calibri" pitchFamily="34" charset="-120"/>
-              </a:rPr>
-              <a:t>KHÁM PHÁ</a:t>
-            </a:r>
-            <a:endParaRPr lang="en-US" sz="1200" dirty="0"/>
-          </a:p>
-        </p:txBody>
-      </p:sp>
-      <p:sp>
-        <p:nvSpPr>
           <p:cNvPr id="3" name="Text 1"/>
           <p:cNvSpPr/>
           <p:nvPr/>
@@ -1585,7 +1321,7 @@
           <a:bodyPr wrap="square" lIns="0" tIns="0" rIns="0" bIns="0" rtlCol="0" anchor="ctr"/>
           <a:lstStyle/>
           <a:p>
-            <a:pPr indent="0" marL="0">
+            <a:pPr marL="0" indent="0">
               <a:buNone/>
             </a:pPr>
             <a:r>
@@ -1624,7 +1360,7 @@
           <a:bodyPr wrap="square" lIns="0" tIns="0" rIns="0" bIns="0" rtlCol="0" anchor="t"/>
           <a:lstStyle/>
           <a:p>
-            <a:pPr indent="0" marL="0">
+            <a:pPr marL="0" indent="0">
               <a:lnSpc>
                 <a:spcPts val="3800"/>
               </a:lnSpc>
@@ -1642,45 +1378,6 @@
               <a:t>Ai đã từng nhờ AI viết giúp một đoạn code chưa?</a:t>
             </a:r>
             <a:endParaRPr lang="en-US" sz="3000" dirty="0"/>
-          </a:p>
-        </p:txBody>
-      </p:sp>
-      <p:sp>
-        <p:nvSpPr>
-          <p:cNvPr id="5" name="Text 3"/>
-          <p:cNvSpPr/>
-          <p:nvPr/>
-        </p:nvSpPr>
-        <p:spPr>
-          <a:xfrm>
-            <a:off x="640080" y="4160520"/>
-            <a:ext cx="5486400" cy="365760"/>
-          </a:xfrm>
-          <a:prstGeom prst="rect">
-            <a:avLst/>
-          </a:prstGeom>
-          <a:noFill/>
-          <a:ln/>
-        </p:spPr>
-        <p:txBody>
-          <a:bodyPr wrap="square" lIns="0" tIns="0" rIns="0" bIns="0" rtlCol="0" anchor="ctr"/>
-          <a:lstStyle/>
-          <a:p>
-            <a:pPr indent="0" marL="0">
-              <a:buNone/>
-            </a:pPr>
-            <a:r>
-              <a:rPr lang="en-US" sz="1300" dirty="0">
-                <a:solidFill>
-                  <a:srgbClr val="6B7280"/>
-                </a:solidFill>
-                <a:latin typeface="Calibri" pitchFamily="34" charset="0"/>
-                <a:ea typeface="Calibri" pitchFamily="34" charset="-122"/>
-                <a:cs typeface="Calibri" pitchFamily="34" charset="-120"/>
-              </a:rPr>
-              <a:t>Câu hỏi mở đầu cho khán giả</a:t>
-            </a:r>
-            <a:endParaRPr lang="en-US" sz="1300" dirty="0"/>
           </a:p>
         </p:txBody>
       </p:sp>
@@ -1705,13 +1402,20 @@
           </a:solidFill>
           <a:ln/>
           <a:effectLst>
-            <a:outerShdw sx="100000" sy="100000" kx="0" ky="0" algn="bl" rotWithShape="0" blurRad="127000" dist="38100" dir="5400000">
+            <a:outerShdw blurRad="127000" dist="38100" dir="5400000" algn="bl" rotWithShape="0">
               <a:srgbClr val="1E2761">
                 <a:alpha val="12000"/>
               </a:srgbClr>
             </a:outerShdw>
           </a:effectLst>
         </p:spPr>
+        <p:txBody>
+          <a:bodyPr/>
+          <a:lstStyle/>
+          <a:p>
+            <a:endParaRPr lang="en-VN"/>
+          </a:p>
+        </p:txBody>
       </p:sp>
       <p:sp>
         <p:nvSpPr>
@@ -1732,17 +1436,24 @@
           </a:solidFill>
           <a:ln/>
         </p:spPr>
+        <p:txBody>
+          <a:bodyPr/>
+          <a:lstStyle/>
+          <a:p>
+            <a:endParaRPr lang="en-VN"/>
+          </a:p>
+        </p:txBody>
       </p:sp>
       <p:pic>
         <p:nvPicPr>
-          <p:cNvPr id="8" name="Image 0" descr="/private/tmp/claude-501/-Users-wanbi-Code-oss-projects-viettyping/819a7611-2cb6-438f-ae7c-0ad07e99bd3f/scratchpad/slides/icons/comments_white.png">    </p:cNvPr>
+          <p:cNvPr id="8" name="Image 0" descr="/private/tmp/claude-501/-Users-wanbi-Code-oss-projects-viettyping/819a7611-2cb6-438f-ae7c-0ad07e99bd3f/scratchpad/slides/icons/comments_white.png"/>
           <p:cNvPicPr>
             <a:picLocks noChangeAspect="1"/>
           </p:cNvPicPr>
           <p:nvPr/>
         </p:nvPicPr>
         <p:blipFill>
-          <a:blip r:embed="rId1"/>
+          <a:blip r:embed="rId3"/>
           <a:stretch>
             <a:fillRect/>
           </a:stretch>
@@ -1778,7 +1489,7 @@
           <a:bodyPr wrap="square" lIns="0" tIns="0" rIns="0" bIns="0" rtlCol="0" anchor="ctr"/>
           <a:lstStyle/>
           <a:p>
-            <a:pPr indent="0" marL="0">
+            <a:pPr marL="0" indent="0">
               <a:buNone/>
             </a:pPr>
             <a:r>
@@ -1817,7 +1528,7 @@
           <a:bodyPr wrap="square" lIns="0" tIns="0" rIns="0" bIns="0" rtlCol="0" anchor="ctr"/>
           <a:lstStyle/>
           <a:p>
-            <a:pPr indent="0" marL="0">
+            <a:pPr marL="0" indent="0">
               <a:lnSpc>
                 <a:spcPts val="2000"/>
               </a:lnSpc>
@@ -1859,7 +1570,7 @@
           <a:bodyPr wrap="square" lIns="0" tIns="0" rIns="0" bIns="0" rtlCol="0" anchor="ctr"/>
           <a:lstStyle/>
           <a:p>
-            <a:pPr indent="0" marL="0">
+            <a:pPr marL="0" indent="0">
               <a:lnSpc>
                 <a:spcPts val="2000"/>
               </a:lnSpc>
@@ -1896,6 +1607,7 @@
         <a:solidFill>
           <a:srgbClr val="FFFFFF"/>
         </a:solidFill>
+        <a:effectLst/>
       </p:bgPr>
     </p:bg>
     <p:spTree>
@@ -1914,14 +1626,14 @@
       </p:grpSpPr>
       <p:sp>
         <p:nvSpPr>
-          <p:cNvPr id="2" name="Text 0"/>
-          <p:cNvSpPr/>
-          <p:nvPr/>
-        </p:nvSpPr>
-        <p:spPr>
-          <a:xfrm>
-            <a:off x="640080" y="502920"/>
-            <a:ext cx="5486400" cy="320040"/>
+          <p:cNvPr id="3" name="Text 1"/>
+          <p:cNvSpPr/>
+          <p:nvPr/>
+        </p:nvSpPr>
+        <p:spPr>
+          <a:xfrm>
+            <a:off x="640080" y="868680"/>
+            <a:ext cx="9144000" cy="685800"/>
           </a:xfrm>
           <a:prstGeom prst="rect">
             <a:avLst/>
@@ -1933,115 +1645,70 @@
           <a:bodyPr wrap="square" lIns="0" tIns="0" rIns="0" bIns="0" rtlCol="0" anchor="ctr"/>
           <a:lstStyle/>
           <a:p>
-            <a:pPr indent="0" marL="0">
-              <a:buNone/>
-            </a:pPr>
-            <a:r>
-              <a:rPr lang="en-US" sz="1200" b="1" spc="300" kern="0" dirty="0">
-                <a:solidFill>
-                  <a:srgbClr val="F96167"/>
+            <a:pPr marL="0" indent="0">
+              <a:buNone/>
+            </a:pPr>
+            <a:r>
+              <a:rPr lang="en-US" sz="3400" b="1" dirty="0">
+                <a:solidFill>
+                  <a:srgbClr val="1E2761"/>
+                </a:solidFill>
+                <a:latin typeface="Cambria" pitchFamily="34" charset="0"/>
+                <a:ea typeface="Cambria" pitchFamily="34" charset="-122"/>
+                <a:cs typeface="Cambria" pitchFamily="34" charset="-120"/>
+              </a:rPr>
+              <a:t>Tư duy AI-Native</a:t>
+            </a:r>
+            <a:endParaRPr lang="en-US" sz="3400" dirty="0"/>
+          </a:p>
+        </p:txBody>
+      </p:sp>
+      <p:sp>
+        <p:nvSpPr>
+          <p:cNvPr id="4" name="Text 2"/>
+          <p:cNvSpPr/>
+          <p:nvPr/>
+        </p:nvSpPr>
+        <p:spPr>
+          <a:xfrm>
+            <a:off x="640080" y="1554480"/>
+            <a:ext cx="9601200" cy="457200"/>
+          </a:xfrm>
+          <a:prstGeom prst="rect">
+            <a:avLst/>
+          </a:prstGeom>
+          <a:noFill/>
+          <a:ln/>
+        </p:spPr>
+        <p:txBody>
+          <a:bodyPr wrap="square" lIns="0" tIns="0" rIns="0" bIns="0" rtlCol="0" anchor="ctr"/>
+          <a:lstStyle/>
+          <a:p>
+            <a:pPr marL="0" indent="0">
+              <a:buNone/>
+            </a:pPr>
+            <a:r>
+              <a:rPr lang="en-US" sz="1600" dirty="0">
+                <a:solidFill>
+                  <a:srgbClr val="1B1B2A"/>
                 </a:solidFill>
                 <a:latin typeface="Calibri" pitchFamily="34" charset="0"/>
                 <a:ea typeface="Calibri" pitchFamily="34" charset="-122"/>
                 <a:cs typeface="Calibri" pitchFamily="34" charset="-120"/>
               </a:rPr>
-              <a:t>KHÁM PHÁ</a:t>
-            </a:r>
-            <a:endParaRPr lang="en-US" sz="1200" dirty="0"/>
-          </a:p>
-        </p:txBody>
-      </p:sp>
-      <p:sp>
-        <p:nvSpPr>
-          <p:cNvPr id="3" name="Text 1"/>
-          <p:cNvSpPr/>
-          <p:nvPr/>
-        </p:nvSpPr>
-        <p:spPr>
-          <a:xfrm>
-            <a:off x="640080" y="868680"/>
-            <a:ext cx="9144000" cy="685800"/>
-          </a:xfrm>
-          <a:prstGeom prst="rect">
-            <a:avLst/>
-          </a:prstGeom>
-          <a:noFill/>
-          <a:ln/>
-        </p:spPr>
-        <p:txBody>
-          <a:bodyPr wrap="square" lIns="0" tIns="0" rIns="0" bIns="0" rtlCol="0" anchor="ctr"/>
-          <a:lstStyle/>
-          <a:p>
-            <a:pPr indent="0" marL="0">
-              <a:buNone/>
-            </a:pPr>
-            <a:r>
-              <a:rPr lang="en-US" sz="3400" b="1" dirty="0">
-                <a:solidFill>
-                  <a:srgbClr val="1E2761"/>
-                </a:solidFill>
-                <a:latin typeface="Cambria" pitchFamily="34" charset="0"/>
-                <a:ea typeface="Cambria" pitchFamily="34" charset="-122"/>
-                <a:cs typeface="Cambria" pitchFamily="34" charset="-120"/>
-              </a:rPr>
-              <a:t>Tư duy AI-Native</a:t>
-            </a:r>
-            <a:endParaRPr lang="en-US" sz="3400" dirty="0"/>
-          </a:p>
-        </p:txBody>
-      </p:sp>
-      <p:sp>
-        <p:nvSpPr>
-          <p:cNvPr id="4" name="Text 2"/>
-          <p:cNvSpPr/>
-          <p:nvPr/>
-        </p:nvSpPr>
-        <p:spPr>
-          <a:xfrm>
-            <a:off x="640080" y="1554480"/>
-            <a:ext cx="9601200" cy="457200"/>
-          </a:xfrm>
-          <a:prstGeom prst="rect">
-            <a:avLst/>
-          </a:prstGeom>
-          <a:noFill/>
-          <a:ln/>
-        </p:spPr>
-        <p:txBody>
-          <a:bodyPr wrap="square" lIns="0" tIns="0" rIns="0" bIns="0" rtlCol="0" anchor="ctr"/>
-          <a:lstStyle/>
-          <a:p>
-            <a:pPr indent="0" marL="0">
-              <a:buNone/>
-            </a:pPr>
-            <a:r>
-              <a:rPr lang="en-US" sz="1600" dirty="0">
-                <a:solidFill>
-                  <a:srgbClr val="1B1B2A"/>
+              <a:t>Kỹ năng quan trọng nhất không còn là </a:t>
+            </a:r>
+            <a:r>
+              <a:rPr lang="en-US" sz="1600" i="1" strike="sngStrike" dirty="0">
+                <a:solidFill>
+                  <a:srgbClr val="6B7280"/>
                 </a:solidFill>
                 <a:latin typeface="Calibri" pitchFamily="34" charset="0"/>
                 <a:ea typeface="Calibri" pitchFamily="34" charset="-122"/>
                 <a:cs typeface="Calibri" pitchFamily="34" charset="-120"/>
               </a:rPr>
-              <a:t>Kỹ năng quan trọng nhất không còn là </a:t>
-            </a:r>
-            <a:pPr indent="0" marL="0">
-              <a:buNone/>
-            </a:pPr>
-            <a:r>
-              <a:rPr lang="en-US" sz="1600" i="1" strike="sngStrike" dirty="0">
-                <a:solidFill>
-                  <a:srgbClr val="6B7280"/>
-                </a:solidFill>
-                <a:latin typeface="Calibri" pitchFamily="34" charset="0"/>
-                <a:ea typeface="Calibri" pitchFamily="34" charset="-122"/>
-                <a:cs typeface="Calibri" pitchFamily="34" charset="-120"/>
-              </a:rPr>
               <a:t>“thuộc cú pháp”</a:t>
             </a:r>
-            <a:pPr indent="0" marL="0">
-              <a:buNone/>
-            </a:pPr>
             <a:r>
               <a:rPr lang="en-US" sz="1600" dirty="0">
                 <a:solidFill>
@@ -2078,13 +1745,20 @@
           </a:solidFill>
           <a:ln/>
           <a:effectLst>
-            <a:outerShdw sx="100000" sy="100000" kx="0" ky="0" algn="bl" rotWithShape="0" blurRad="101600" dist="25400" dir="5400000">
+            <a:outerShdw blurRad="101600" dist="25400" dir="5400000" algn="bl" rotWithShape="0">
               <a:srgbClr val="1E2761">
                 <a:alpha val="10000"/>
               </a:srgbClr>
             </a:outerShdw>
           </a:effectLst>
         </p:spPr>
+        <p:txBody>
+          <a:bodyPr/>
+          <a:lstStyle/>
+          <a:p>
+            <a:endParaRPr lang="en-VN"/>
+          </a:p>
+        </p:txBody>
       </p:sp>
       <p:sp>
         <p:nvSpPr>
@@ -2105,396 +1779,17 @@
           </a:solidFill>
           <a:ln/>
         </p:spPr>
+        <p:txBody>
+          <a:bodyPr/>
+          <a:lstStyle/>
+          <a:p>
+            <a:endParaRPr lang="en-VN"/>
+          </a:p>
+        </p:txBody>
       </p:sp>
       <p:pic>
         <p:nvPicPr>
-          <p:cNvPr id="7" name="Image 0" descr="/private/tmp/claude-501/-Users-wanbi-Code-oss-projects-viettyping/819a7611-2cb6-438f-ae7c-0ad07e99bd3f/scratchpad/slides/icons/question_white.png">    </p:cNvPr>
-          <p:cNvPicPr>
-            <a:picLocks noChangeAspect="1"/>
-          </p:cNvPicPr>
-          <p:nvPr/>
-        </p:nvPicPr>
-        <p:blipFill>
-          <a:blip r:embed="rId1"/>
-          <a:stretch>
-            <a:fillRect/>
-          </a:stretch>
-        </p:blipFill>
-        <p:spPr>
-          <a:xfrm>
-            <a:off x="1161288" y="2898648"/>
-            <a:ext cx="466344" cy="466344"/>
-          </a:xfrm>
-          <a:prstGeom prst="rect">
-            <a:avLst/>
-          </a:prstGeom>
-        </p:spPr>
-      </p:pic>
-      <p:sp>
-        <p:nvSpPr>
-          <p:cNvPr id="8" name="Text 5"/>
-          <p:cNvSpPr/>
-          <p:nvPr/>
-        </p:nvSpPr>
-        <p:spPr>
-          <a:xfrm>
-            <a:off x="3108960" y="2651760"/>
-            <a:ext cx="731520" cy="457200"/>
-          </a:xfrm>
-          <a:prstGeom prst="rect">
-            <a:avLst/>
-          </a:prstGeom>
-          <a:noFill/>
-          <a:ln/>
-        </p:spPr>
-        <p:txBody>
-          <a:bodyPr wrap="square" lIns="0" tIns="0" rIns="0" bIns="0" rtlCol="0" anchor="ctr"/>
-          <a:lstStyle/>
-          <a:p>
-            <a:pPr algn="r" indent="0" marL="0">
-              <a:buNone/>
-            </a:pPr>
-            <a:r>
-              <a:rPr lang="en-US" sz="2000" b="1" dirty="0">
-                <a:solidFill>
-                  <a:srgbClr val="CADCFC"/>
-                </a:solidFill>
-                <a:latin typeface="Cambria" pitchFamily="34" charset="0"/>
-                <a:ea typeface="Cambria" pitchFamily="34" charset="-122"/>
-                <a:cs typeface="Cambria" pitchFamily="34" charset="-120"/>
-              </a:rPr>
-              <a:t>01</a:t>
-            </a:r>
-            <a:endParaRPr lang="en-US" sz="2000" dirty="0"/>
-          </a:p>
-        </p:txBody>
-      </p:sp>
-      <p:sp>
-        <p:nvSpPr>
-          <p:cNvPr id="9" name="Text 6"/>
-          <p:cNvSpPr/>
-          <p:nvPr/>
-        </p:nvSpPr>
-        <p:spPr>
-          <a:xfrm>
-            <a:off x="960120" y="3749040"/>
-            <a:ext cx="2788920" cy="548640"/>
-          </a:xfrm>
-          <a:prstGeom prst="rect">
-            <a:avLst/>
-          </a:prstGeom>
-          <a:noFill/>
-          <a:ln/>
-        </p:spPr>
-        <p:txBody>
-          <a:bodyPr wrap="square" lIns="0" tIns="0" rIns="0" bIns="0" rtlCol="0" anchor="ctr"/>
-          <a:lstStyle/>
-          <a:p>
-            <a:pPr indent="0" marL="0">
-              <a:buNone/>
-            </a:pPr>
-            <a:r>
-              <a:rPr lang="en-US" sz="1700" b="1" dirty="0">
-                <a:solidFill>
-                  <a:srgbClr val="1E2761"/>
-                </a:solidFill>
-                <a:latin typeface="Cambria" pitchFamily="34" charset="0"/>
-                <a:ea typeface="Cambria" pitchFamily="34" charset="-122"/>
-                <a:cs typeface="Cambria" pitchFamily="34" charset="-120"/>
-              </a:rPr>
-              <a:t>Đặt câu hỏi đúng</a:t>
-            </a:r>
-            <a:endParaRPr lang="en-US" sz="1700" dirty="0"/>
-          </a:p>
-        </p:txBody>
-      </p:sp>
-      <p:sp>
-        <p:nvSpPr>
-          <p:cNvPr id="10" name="Text 7"/>
-          <p:cNvSpPr/>
-          <p:nvPr/>
-        </p:nvSpPr>
-        <p:spPr>
-          <a:xfrm>
-            <a:off x="960120" y="4297680"/>
-            <a:ext cx="2788920" cy="1188720"/>
-          </a:xfrm>
-          <a:prstGeom prst="rect">
-            <a:avLst/>
-          </a:prstGeom>
-          <a:noFill/>
-          <a:ln/>
-        </p:spPr>
-        <p:txBody>
-          <a:bodyPr wrap="square" lIns="0" tIns="0" rIns="0" bIns="0" rtlCol="0" anchor="ctr"/>
-          <a:lstStyle/>
-          <a:p>
-            <a:pPr indent="0" marL="0">
-              <a:lnSpc>
-                <a:spcPts val="1800"/>
-              </a:lnSpc>
-              <a:buNone/>
-            </a:pPr>
-            <a:r>
-              <a:rPr lang="en-US" sz="1300" dirty="0">
-                <a:solidFill>
-                  <a:srgbClr val="1B1B2A"/>
-                </a:solidFill>
-                <a:latin typeface="Calibri" pitchFamily="34" charset="0"/>
-                <a:ea typeface="Calibri" pitchFamily="34" charset="-122"/>
-                <a:cs typeface="Calibri" pitchFamily="34" charset="-120"/>
-              </a:rPr>
-              <a:t>Mô tả rõ ý muốn, ràng buộc, và tiêu chí thành công cho AI.</a:t>
-            </a:r>
-            <a:endParaRPr lang="en-US" sz="1300" dirty="0"/>
-          </a:p>
-        </p:txBody>
-      </p:sp>
-      <p:sp>
-        <p:nvSpPr>
-          <p:cNvPr id="11" name="Shape 8"/>
-          <p:cNvSpPr/>
-          <p:nvPr/>
-        </p:nvSpPr>
-        <p:spPr>
-          <a:xfrm>
-            <a:off x="4389120" y="2331720"/>
-            <a:ext cx="3429000" cy="3291840"/>
-          </a:xfrm>
-          <a:prstGeom prst="roundRect">
-            <a:avLst>
-              <a:gd name="adj" fmla="val 3889"/>
-            </a:avLst>
-          </a:prstGeom>
-          <a:solidFill>
-            <a:srgbClr val="F7F8FC"/>
-          </a:solidFill>
-          <a:ln/>
-          <a:effectLst>
-            <a:outerShdw sx="100000" sy="100000" kx="0" ky="0" algn="bl" rotWithShape="0" blurRad="101600" dist="25400" dir="5400000">
-              <a:srgbClr val="1E2761">
-                <a:alpha val="10000"/>
-              </a:srgbClr>
-            </a:outerShdw>
-          </a:effectLst>
-        </p:spPr>
-      </p:sp>
-      <p:sp>
-        <p:nvSpPr>
-          <p:cNvPr id="12" name="Shape 9"/>
-          <p:cNvSpPr/>
-          <p:nvPr/>
-        </p:nvSpPr>
-        <p:spPr>
-          <a:xfrm>
-            <a:off x="4709160" y="2697480"/>
-            <a:ext cx="868680" cy="868680"/>
-          </a:xfrm>
-          <a:prstGeom prst="ellipse">
-            <a:avLst/>
-          </a:prstGeom>
-          <a:solidFill>
-            <a:srgbClr val="F96167"/>
-          </a:solidFill>
-          <a:ln/>
-        </p:spPr>
-      </p:sp>
-      <p:pic>
-        <p:nvPicPr>
-          <p:cNvPr id="13" name="Image 1" descr="/private/tmp/claude-501/-Users-wanbi-Code-oss-projects-viettyping/819a7611-2cb6-438f-ae7c-0ad07e99bd3f/scratchpad/slides/icons/search_white.png">    </p:cNvPr>
-          <p:cNvPicPr>
-            <a:picLocks noChangeAspect="1"/>
-          </p:cNvPicPr>
-          <p:nvPr/>
-        </p:nvPicPr>
-        <p:blipFill>
-          <a:blip r:embed="rId2"/>
-          <a:stretch>
-            <a:fillRect/>
-          </a:stretch>
-        </p:blipFill>
-        <p:spPr>
-          <a:xfrm>
-            <a:off x="4910328" y="2898648"/>
-            <a:ext cx="466344" cy="466344"/>
-          </a:xfrm>
-          <a:prstGeom prst="rect">
-            <a:avLst/>
-          </a:prstGeom>
-        </p:spPr>
-      </p:pic>
-      <p:sp>
-        <p:nvSpPr>
-          <p:cNvPr id="14" name="Text 10"/>
-          <p:cNvSpPr/>
-          <p:nvPr/>
-        </p:nvSpPr>
-        <p:spPr>
-          <a:xfrm>
-            <a:off x="6858000" y="2651760"/>
-            <a:ext cx="731520" cy="457200"/>
-          </a:xfrm>
-          <a:prstGeom prst="rect">
-            <a:avLst/>
-          </a:prstGeom>
-          <a:noFill/>
-          <a:ln/>
-        </p:spPr>
-        <p:txBody>
-          <a:bodyPr wrap="square" lIns="0" tIns="0" rIns="0" bIns="0" rtlCol="0" anchor="ctr"/>
-          <a:lstStyle/>
-          <a:p>
-            <a:pPr algn="r" indent="0" marL="0">
-              <a:buNone/>
-            </a:pPr>
-            <a:r>
-              <a:rPr lang="en-US" sz="2000" b="1" dirty="0">
-                <a:solidFill>
-                  <a:srgbClr val="CADCFC"/>
-                </a:solidFill>
-                <a:latin typeface="Cambria" pitchFamily="34" charset="0"/>
-                <a:ea typeface="Cambria" pitchFamily="34" charset="-122"/>
-                <a:cs typeface="Cambria" pitchFamily="34" charset="-120"/>
-              </a:rPr>
-              <a:t>02</a:t>
-            </a:r>
-            <a:endParaRPr lang="en-US" sz="2000" dirty="0"/>
-          </a:p>
-        </p:txBody>
-      </p:sp>
-      <p:sp>
-        <p:nvSpPr>
-          <p:cNvPr id="15" name="Text 11"/>
-          <p:cNvSpPr/>
-          <p:nvPr/>
-        </p:nvSpPr>
-        <p:spPr>
-          <a:xfrm>
-            <a:off x="4709160" y="3749040"/>
-            <a:ext cx="2788920" cy="548640"/>
-          </a:xfrm>
-          <a:prstGeom prst="rect">
-            <a:avLst/>
-          </a:prstGeom>
-          <a:noFill/>
-          <a:ln/>
-        </p:spPr>
-        <p:txBody>
-          <a:bodyPr wrap="square" lIns="0" tIns="0" rIns="0" bIns="0" rtlCol="0" anchor="ctr"/>
-          <a:lstStyle/>
-          <a:p>
-            <a:pPr indent="0" marL="0">
-              <a:buNone/>
-            </a:pPr>
-            <a:r>
-              <a:rPr lang="en-US" sz="1700" b="1" dirty="0">
-                <a:solidFill>
-                  <a:srgbClr val="1E2761"/>
-                </a:solidFill>
-                <a:latin typeface="Cambria" pitchFamily="34" charset="0"/>
-                <a:ea typeface="Cambria" pitchFamily="34" charset="-122"/>
-                <a:cs typeface="Cambria" pitchFamily="34" charset="-120"/>
-              </a:rPr>
-              <a:t>Đọc và đánh giá kết quả</a:t>
-            </a:r>
-            <a:endParaRPr lang="en-US" sz="1700" dirty="0"/>
-          </a:p>
-        </p:txBody>
-      </p:sp>
-      <p:sp>
-        <p:nvSpPr>
-          <p:cNvPr id="16" name="Text 12"/>
-          <p:cNvSpPr/>
-          <p:nvPr/>
-        </p:nvSpPr>
-        <p:spPr>
-          <a:xfrm>
-            <a:off x="4709160" y="4297680"/>
-            <a:ext cx="2788920" cy="1188720"/>
-          </a:xfrm>
-          <a:prstGeom prst="rect">
-            <a:avLst/>
-          </a:prstGeom>
-          <a:noFill/>
-          <a:ln/>
-        </p:spPr>
-        <p:txBody>
-          <a:bodyPr wrap="square" lIns="0" tIns="0" rIns="0" bIns="0" rtlCol="0" anchor="ctr"/>
-          <a:lstStyle/>
-          <a:p>
-            <a:pPr indent="0" marL="0">
-              <a:lnSpc>
-                <a:spcPts val="1800"/>
-              </a:lnSpc>
-              <a:buNone/>
-            </a:pPr>
-            <a:r>
-              <a:rPr lang="en-US" sz="1300" dirty="0">
-                <a:solidFill>
-                  <a:srgbClr val="1B1B2A"/>
-                </a:solidFill>
-                <a:latin typeface="Calibri" pitchFamily="34" charset="0"/>
-                <a:ea typeface="Calibri" pitchFamily="34" charset="-122"/>
-                <a:cs typeface="Calibri" pitchFamily="34" charset="-120"/>
-              </a:rPr>
-              <a:t>Kiểm tra AI đưa ra đúng ý chưa, phát hiện chỗ lệch sớm.</a:t>
-            </a:r>
-            <a:endParaRPr lang="en-US" sz="1300" dirty="0"/>
-          </a:p>
-        </p:txBody>
-      </p:sp>
-      <p:sp>
-        <p:nvSpPr>
-          <p:cNvPr id="17" name="Shape 13"/>
-          <p:cNvSpPr/>
-          <p:nvPr/>
-        </p:nvSpPr>
-        <p:spPr>
-          <a:xfrm>
-            <a:off x="8138160" y="2331720"/>
-            <a:ext cx="3429000" cy="3291840"/>
-          </a:xfrm>
-          <a:prstGeom prst="roundRect">
-            <a:avLst>
-              <a:gd name="adj" fmla="val 3889"/>
-            </a:avLst>
-          </a:prstGeom>
-          <a:solidFill>
-            <a:srgbClr val="F7F8FC"/>
-          </a:solidFill>
-          <a:ln/>
-          <a:effectLst>
-            <a:outerShdw sx="100000" sy="100000" kx="0" ky="0" algn="bl" rotWithShape="0" blurRad="101600" dist="25400" dir="5400000">
-              <a:srgbClr val="1E2761">
-                <a:alpha val="10000"/>
-              </a:srgbClr>
-            </a:outerShdw>
-          </a:effectLst>
-        </p:spPr>
-      </p:sp>
-      <p:sp>
-        <p:nvSpPr>
-          <p:cNvPr id="18" name="Shape 14"/>
-          <p:cNvSpPr/>
-          <p:nvPr/>
-        </p:nvSpPr>
-        <p:spPr>
-          <a:xfrm>
-            <a:off x="8458200" y="2697480"/>
-            <a:ext cx="868680" cy="868680"/>
-          </a:xfrm>
-          <a:prstGeom prst="ellipse">
-            <a:avLst/>
-          </a:prstGeom>
-          <a:solidFill>
-            <a:srgbClr val="1E2761"/>
-          </a:solidFill>
-          <a:ln/>
-        </p:spPr>
-      </p:sp>
-      <p:pic>
-        <p:nvPicPr>
-          <p:cNvPr id="19" name="Image 2" descr="/private/tmp/claude-501/-Users-wanbi-Code-oss-projects-viettyping/819a7611-2cb6-438f-ae7c-0ad07e99bd3f/scratchpad/slides/icons/sync_white.png">    </p:cNvPr>
+          <p:cNvPr id="7" name="Image 0" descr="/private/tmp/claude-501/-Users-wanbi-Code-oss-projects-viettyping/819a7611-2cb6-438f-ae7c-0ad07e99bd3f/scratchpad/slides/icons/question_white.png"/>
           <p:cNvPicPr>
             <a:picLocks noChangeAspect="1"/>
           </p:cNvPicPr>
@@ -2508,7 +1803,7 @@
         </p:blipFill>
         <p:spPr>
           <a:xfrm>
-            <a:off x="8659368" y="2898648"/>
+            <a:off x="1161288" y="2898648"/>
             <a:ext cx="466344" cy="466344"/>
           </a:xfrm>
           <a:prstGeom prst="rect">
@@ -2518,13 +1813,13 @@
       </p:pic>
       <p:sp>
         <p:nvSpPr>
-          <p:cNvPr id="20" name="Text 15"/>
-          <p:cNvSpPr/>
-          <p:nvPr/>
-        </p:nvSpPr>
-        <p:spPr>
-          <a:xfrm>
-            <a:off x="10607040" y="2651760"/>
+          <p:cNvPr id="8" name="Text 5"/>
+          <p:cNvSpPr/>
+          <p:nvPr/>
+        </p:nvSpPr>
+        <p:spPr>
+          <a:xfrm>
+            <a:off x="3108960" y="2651760"/>
             <a:ext cx="731520" cy="457200"/>
           </a:xfrm>
           <a:prstGeom prst="rect">
@@ -2537,7 +1832,7 @@
           <a:bodyPr wrap="square" lIns="0" tIns="0" rIns="0" bIns="0" rtlCol="0" anchor="ctr"/>
           <a:lstStyle/>
           <a:p>
-            <a:pPr algn="r" indent="0" marL="0">
+            <a:pPr marL="0" indent="0" algn="r">
               <a:buNone/>
             </a:pPr>
             <a:r>
@@ -2549,7 +1844,7 @@
                 <a:ea typeface="Cambria" pitchFamily="34" charset="-122"/>
                 <a:cs typeface="Cambria" pitchFamily="34" charset="-120"/>
               </a:rPr>
-              <a:t>03</a:t>
+              <a:t>01</a:t>
             </a:r>
             <a:endParaRPr lang="en-US" sz="2000" dirty="0"/>
           </a:p>
@@ -2557,13 +1852,13 @@
       </p:sp>
       <p:sp>
         <p:nvSpPr>
-          <p:cNvPr id="21" name="Text 16"/>
-          <p:cNvSpPr/>
-          <p:nvPr/>
-        </p:nvSpPr>
-        <p:spPr>
-          <a:xfrm>
-            <a:off x="8458200" y="3749040"/>
+          <p:cNvPr id="9" name="Text 6"/>
+          <p:cNvSpPr/>
+          <p:nvPr/>
+        </p:nvSpPr>
+        <p:spPr>
+          <a:xfrm>
+            <a:off x="960120" y="3749040"/>
             <a:ext cx="2788920" cy="548640"/>
           </a:xfrm>
           <a:prstGeom prst="rect">
@@ -2576,7 +1871,7 @@
           <a:bodyPr wrap="square" lIns="0" tIns="0" rIns="0" bIns="0" rtlCol="0" anchor="ctr"/>
           <a:lstStyle/>
           <a:p>
-            <a:pPr indent="0" marL="0">
+            <a:pPr marL="0" indent="0">
               <a:buNone/>
             </a:pPr>
             <a:r>
@@ -2588,6 +1883,420 @@
                 <a:ea typeface="Cambria" pitchFamily="34" charset="-122"/>
                 <a:cs typeface="Cambria" pitchFamily="34" charset="-120"/>
               </a:rPr>
+              <a:t>Đặt câu hỏi đúng</a:t>
+            </a:r>
+            <a:endParaRPr lang="en-US" sz="1700" dirty="0"/>
+          </a:p>
+        </p:txBody>
+      </p:sp>
+      <p:sp>
+        <p:nvSpPr>
+          <p:cNvPr id="10" name="Text 7"/>
+          <p:cNvSpPr/>
+          <p:nvPr/>
+        </p:nvSpPr>
+        <p:spPr>
+          <a:xfrm>
+            <a:off x="960120" y="4297680"/>
+            <a:ext cx="2788920" cy="1188720"/>
+          </a:xfrm>
+          <a:prstGeom prst="rect">
+            <a:avLst/>
+          </a:prstGeom>
+          <a:noFill/>
+          <a:ln/>
+        </p:spPr>
+        <p:txBody>
+          <a:bodyPr wrap="square" lIns="0" tIns="0" rIns="0" bIns="0" rtlCol="0" anchor="ctr"/>
+          <a:lstStyle/>
+          <a:p>
+            <a:pPr marL="0" indent="0">
+              <a:lnSpc>
+                <a:spcPts val="1800"/>
+              </a:lnSpc>
+              <a:buNone/>
+            </a:pPr>
+            <a:r>
+              <a:rPr lang="en-US" sz="1300" dirty="0">
+                <a:solidFill>
+                  <a:srgbClr val="1B1B2A"/>
+                </a:solidFill>
+                <a:latin typeface="Calibri" pitchFamily="34" charset="0"/>
+                <a:ea typeface="Calibri" pitchFamily="34" charset="-122"/>
+                <a:cs typeface="Calibri" pitchFamily="34" charset="-120"/>
+              </a:rPr>
+              <a:t>Mô tả rõ ý muốn, ràng buộc, và tiêu chí thành công cho AI.</a:t>
+            </a:r>
+            <a:endParaRPr lang="en-US" sz="1300" dirty="0"/>
+          </a:p>
+        </p:txBody>
+      </p:sp>
+      <p:sp>
+        <p:nvSpPr>
+          <p:cNvPr id="11" name="Shape 8"/>
+          <p:cNvSpPr/>
+          <p:nvPr/>
+        </p:nvSpPr>
+        <p:spPr>
+          <a:xfrm>
+            <a:off x="4389120" y="2331720"/>
+            <a:ext cx="3429000" cy="3291840"/>
+          </a:xfrm>
+          <a:prstGeom prst="roundRect">
+            <a:avLst>
+              <a:gd name="adj" fmla="val 3889"/>
+            </a:avLst>
+          </a:prstGeom>
+          <a:solidFill>
+            <a:srgbClr val="F7F8FC"/>
+          </a:solidFill>
+          <a:ln/>
+          <a:effectLst>
+            <a:outerShdw blurRad="101600" dist="25400" dir="5400000" algn="bl" rotWithShape="0">
+              <a:srgbClr val="1E2761">
+                <a:alpha val="10000"/>
+              </a:srgbClr>
+            </a:outerShdw>
+          </a:effectLst>
+        </p:spPr>
+        <p:txBody>
+          <a:bodyPr/>
+          <a:lstStyle/>
+          <a:p>
+            <a:endParaRPr lang="en-VN"/>
+          </a:p>
+        </p:txBody>
+      </p:sp>
+      <p:sp>
+        <p:nvSpPr>
+          <p:cNvPr id="12" name="Shape 9"/>
+          <p:cNvSpPr/>
+          <p:nvPr/>
+        </p:nvSpPr>
+        <p:spPr>
+          <a:xfrm>
+            <a:off x="4709160" y="2697480"/>
+            <a:ext cx="868680" cy="868680"/>
+          </a:xfrm>
+          <a:prstGeom prst="ellipse">
+            <a:avLst/>
+          </a:prstGeom>
+          <a:solidFill>
+            <a:srgbClr val="F96167"/>
+          </a:solidFill>
+          <a:ln/>
+        </p:spPr>
+        <p:txBody>
+          <a:bodyPr/>
+          <a:lstStyle/>
+          <a:p>
+            <a:endParaRPr lang="en-VN"/>
+          </a:p>
+        </p:txBody>
+      </p:sp>
+      <p:pic>
+        <p:nvPicPr>
+          <p:cNvPr id="13" name="Image 1" descr="/private/tmp/claude-501/-Users-wanbi-Code-oss-projects-viettyping/819a7611-2cb6-438f-ae7c-0ad07e99bd3f/scratchpad/slides/icons/search_white.png"/>
+          <p:cNvPicPr>
+            <a:picLocks noChangeAspect="1"/>
+          </p:cNvPicPr>
+          <p:nvPr/>
+        </p:nvPicPr>
+        <p:blipFill>
+          <a:blip r:embed="rId4"/>
+          <a:stretch>
+            <a:fillRect/>
+          </a:stretch>
+        </p:blipFill>
+        <p:spPr>
+          <a:xfrm>
+            <a:off x="4910328" y="2898648"/>
+            <a:ext cx="466344" cy="466344"/>
+          </a:xfrm>
+          <a:prstGeom prst="rect">
+            <a:avLst/>
+          </a:prstGeom>
+        </p:spPr>
+      </p:pic>
+      <p:sp>
+        <p:nvSpPr>
+          <p:cNvPr id="14" name="Text 10"/>
+          <p:cNvSpPr/>
+          <p:nvPr/>
+        </p:nvSpPr>
+        <p:spPr>
+          <a:xfrm>
+            <a:off x="6858000" y="2651760"/>
+            <a:ext cx="731520" cy="457200"/>
+          </a:xfrm>
+          <a:prstGeom prst="rect">
+            <a:avLst/>
+          </a:prstGeom>
+          <a:noFill/>
+          <a:ln/>
+        </p:spPr>
+        <p:txBody>
+          <a:bodyPr wrap="square" lIns="0" tIns="0" rIns="0" bIns="0" rtlCol="0" anchor="ctr"/>
+          <a:lstStyle/>
+          <a:p>
+            <a:pPr marL="0" indent="0" algn="r">
+              <a:buNone/>
+            </a:pPr>
+            <a:r>
+              <a:rPr lang="en-US" sz="2000" b="1" dirty="0">
+                <a:solidFill>
+                  <a:srgbClr val="CADCFC"/>
+                </a:solidFill>
+                <a:latin typeface="Cambria" pitchFamily="34" charset="0"/>
+                <a:ea typeface="Cambria" pitchFamily="34" charset="-122"/>
+                <a:cs typeface="Cambria" pitchFamily="34" charset="-120"/>
+              </a:rPr>
+              <a:t>02</a:t>
+            </a:r>
+            <a:endParaRPr lang="en-US" sz="2000" dirty="0"/>
+          </a:p>
+        </p:txBody>
+      </p:sp>
+      <p:sp>
+        <p:nvSpPr>
+          <p:cNvPr id="15" name="Text 11"/>
+          <p:cNvSpPr/>
+          <p:nvPr/>
+        </p:nvSpPr>
+        <p:spPr>
+          <a:xfrm>
+            <a:off x="4709160" y="3749040"/>
+            <a:ext cx="2788920" cy="548640"/>
+          </a:xfrm>
+          <a:prstGeom prst="rect">
+            <a:avLst/>
+          </a:prstGeom>
+          <a:noFill/>
+          <a:ln/>
+        </p:spPr>
+        <p:txBody>
+          <a:bodyPr wrap="square" lIns="0" tIns="0" rIns="0" bIns="0" rtlCol="0" anchor="ctr"/>
+          <a:lstStyle/>
+          <a:p>
+            <a:pPr marL="0" indent="0">
+              <a:buNone/>
+            </a:pPr>
+            <a:r>
+              <a:rPr lang="en-US" sz="1700" b="1" dirty="0">
+                <a:solidFill>
+                  <a:srgbClr val="1E2761"/>
+                </a:solidFill>
+                <a:latin typeface="Cambria" pitchFamily="34" charset="0"/>
+                <a:ea typeface="Cambria" pitchFamily="34" charset="-122"/>
+                <a:cs typeface="Cambria" pitchFamily="34" charset="-120"/>
+              </a:rPr>
+              <a:t>Đọc và đánh giá kết quả</a:t>
+            </a:r>
+            <a:endParaRPr lang="en-US" sz="1700" dirty="0"/>
+          </a:p>
+        </p:txBody>
+      </p:sp>
+      <p:sp>
+        <p:nvSpPr>
+          <p:cNvPr id="16" name="Text 12"/>
+          <p:cNvSpPr/>
+          <p:nvPr/>
+        </p:nvSpPr>
+        <p:spPr>
+          <a:xfrm>
+            <a:off x="4709160" y="4297680"/>
+            <a:ext cx="2788920" cy="1188720"/>
+          </a:xfrm>
+          <a:prstGeom prst="rect">
+            <a:avLst/>
+          </a:prstGeom>
+          <a:noFill/>
+          <a:ln/>
+        </p:spPr>
+        <p:txBody>
+          <a:bodyPr wrap="square" lIns="0" tIns="0" rIns="0" bIns="0" rtlCol="0" anchor="ctr"/>
+          <a:lstStyle/>
+          <a:p>
+            <a:pPr marL="0" indent="0">
+              <a:lnSpc>
+                <a:spcPts val="1800"/>
+              </a:lnSpc>
+              <a:buNone/>
+            </a:pPr>
+            <a:r>
+              <a:rPr lang="en-US" sz="1300" dirty="0">
+                <a:solidFill>
+                  <a:srgbClr val="1B1B2A"/>
+                </a:solidFill>
+                <a:latin typeface="Calibri" pitchFamily="34" charset="0"/>
+                <a:ea typeface="Calibri" pitchFamily="34" charset="-122"/>
+                <a:cs typeface="Calibri" pitchFamily="34" charset="-120"/>
+              </a:rPr>
+              <a:t>Kiểm tra AI đưa ra đúng ý chưa, phát hiện chỗ lệch sớm.</a:t>
+            </a:r>
+            <a:endParaRPr lang="en-US" sz="1300" dirty="0"/>
+          </a:p>
+        </p:txBody>
+      </p:sp>
+      <p:sp>
+        <p:nvSpPr>
+          <p:cNvPr id="17" name="Shape 13"/>
+          <p:cNvSpPr/>
+          <p:nvPr/>
+        </p:nvSpPr>
+        <p:spPr>
+          <a:xfrm>
+            <a:off x="8138160" y="2331720"/>
+            <a:ext cx="3429000" cy="3291840"/>
+          </a:xfrm>
+          <a:prstGeom prst="roundRect">
+            <a:avLst>
+              <a:gd name="adj" fmla="val 3889"/>
+            </a:avLst>
+          </a:prstGeom>
+          <a:solidFill>
+            <a:srgbClr val="F7F8FC"/>
+          </a:solidFill>
+          <a:ln/>
+          <a:effectLst>
+            <a:outerShdw blurRad="101600" dist="25400" dir="5400000" algn="bl" rotWithShape="0">
+              <a:srgbClr val="1E2761">
+                <a:alpha val="10000"/>
+              </a:srgbClr>
+            </a:outerShdw>
+          </a:effectLst>
+        </p:spPr>
+        <p:txBody>
+          <a:bodyPr/>
+          <a:lstStyle/>
+          <a:p>
+            <a:endParaRPr lang="en-VN"/>
+          </a:p>
+        </p:txBody>
+      </p:sp>
+      <p:sp>
+        <p:nvSpPr>
+          <p:cNvPr id="18" name="Shape 14"/>
+          <p:cNvSpPr/>
+          <p:nvPr/>
+        </p:nvSpPr>
+        <p:spPr>
+          <a:xfrm>
+            <a:off x="8458200" y="2697480"/>
+            <a:ext cx="868680" cy="868680"/>
+          </a:xfrm>
+          <a:prstGeom prst="ellipse">
+            <a:avLst/>
+          </a:prstGeom>
+          <a:solidFill>
+            <a:srgbClr val="1E2761"/>
+          </a:solidFill>
+          <a:ln/>
+        </p:spPr>
+        <p:txBody>
+          <a:bodyPr/>
+          <a:lstStyle/>
+          <a:p>
+            <a:endParaRPr lang="en-VN"/>
+          </a:p>
+        </p:txBody>
+      </p:sp>
+      <p:pic>
+        <p:nvPicPr>
+          <p:cNvPr id="19" name="Image 2" descr="/private/tmp/claude-501/-Users-wanbi-Code-oss-projects-viettyping/819a7611-2cb6-438f-ae7c-0ad07e99bd3f/scratchpad/slides/icons/sync_white.png"/>
+          <p:cNvPicPr>
+            <a:picLocks noChangeAspect="1"/>
+          </p:cNvPicPr>
+          <p:nvPr/>
+        </p:nvPicPr>
+        <p:blipFill>
+          <a:blip r:embed="rId5"/>
+          <a:stretch>
+            <a:fillRect/>
+          </a:stretch>
+        </p:blipFill>
+        <p:spPr>
+          <a:xfrm>
+            <a:off x="8659368" y="2898648"/>
+            <a:ext cx="466344" cy="466344"/>
+          </a:xfrm>
+          <a:prstGeom prst="rect">
+            <a:avLst/>
+          </a:prstGeom>
+        </p:spPr>
+      </p:pic>
+      <p:sp>
+        <p:nvSpPr>
+          <p:cNvPr id="20" name="Text 15"/>
+          <p:cNvSpPr/>
+          <p:nvPr/>
+        </p:nvSpPr>
+        <p:spPr>
+          <a:xfrm>
+            <a:off x="10607040" y="2651760"/>
+            <a:ext cx="731520" cy="457200"/>
+          </a:xfrm>
+          <a:prstGeom prst="rect">
+            <a:avLst/>
+          </a:prstGeom>
+          <a:noFill/>
+          <a:ln/>
+        </p:spPr>
+        <p:txBody>
+          <a:bodyPr wrap="square" lIns="0" tIns="0" rIns="0" bIns="0" rtlCol="0" anchor="ctr"/>
+          <a:lstStyle/>
+          <a:p>
+            <a:pPr marL="0" indent="0" algn="r">
+              <a:buNone/>
+            </a:pPr>
+            <a:r>
+              <a:rPr lang="en-US" sz="2000" b="1" dirty="0">
+                <a:solidFill>
+                  <a:srgbClr val="CADCFC"/>
+                </a:solidFill>
+                <a:latin typeface="Cambria" pitchFamily="34" charset="0"/>
+                <a:ea typeface="Cambria" pitchFamily="34" charset="-122"/>
+                <a:cs typeface="Cambria" pitchFamily="34" charset="-120"/>
+              </a:rPr>
+              <a:t>03</a:t>
+            </a:r>
+            <a:endParaRPr lang="en-US" sz="2000" dirty="0"/>
+          </a:p>
+        </p:txBody>
+      </p:sp>
+      <p:sp>
+        <p:nvSpPr>
+          <p:cNvPr id="21" name="Text 16"/>
+          <p:cNvSpPr/>
+          <p:nvPr/>
+        </p:nvSpPr>
+        <p:spPr>
+          <a:xfrm>
+            <a:off x="8458200" y="3749040"/>
+            <a:ext cx="2788920" cy="548640"/>
+          </a:xfrm>
+          <a:prstGeom prst="rect">
+            <a:avLst/>
+          </a:prstGeom>
+          <a:noFill/>
+          <a:ln/>
+        </p:spPr>
+        <p:txBody>
+          <a:bodyPr wrap="square" lIns="0" tIns="0" rIns="0" bIns="0" rtlCol="0" anchor="ctr"/>
+          <a:lstStyle/>
+          <a:p>
+            <a:pPr marL="0" indent="0">
+              <a:buNone/>
+            </a:pPr>
+            <a:r>
+              <a:rPr lang="en-US" sz="1700" b="1" dirty="0">
+                <a:solidFill>
+                  <a:srgbClr val="1E2761"/>
+                </a:solidFill>
+                <a:latin typeface="Cambria" pitchFamily="34" charset="0"/>
+                <a:ea typeface="Cambria" pitchFamily="34" charset="-122"/>
+                <a:cs typeface="Cambria" pitchFamily="34" charset="-120"/>
+              </a:rPr>
               <a:t>Lặp lại thật nhanh</a:t>
             </a:r>
             <a:endParaRPr lang="en-US" sz="1700" dirty="0"/>
@@ -2615,7 +2324,7 @@
           <a:bodyPr wrap="square" lIns="0" tIns="0" rIns="0" bIns="0" rtlCol="0" anchor="ctr"/>
           <a:lstStyle/>
           <a:p>
-            <a:pPr indent="0" marL="0">
+            <a:pPr marL="0" indent="0">
               <a:lnSpc>
                 <a:spcPts val="1800"/>
               </a:lnSpc>
@@ -2652,6 +2361,7 @@
         <a:solidFill>
           <a:srgbClr val="1E2761"/>
         </a:solidFill>
+        <a:effectLst/>
       </p:bgPr>
     </p:bg>
     <p:spTree>
@@ -2689,11 +2399,11 @@
           <a:bodyPr wrap="square" lIns="0" tIns="0" rIns="0" bIns="0" rtlCol="0" anchor="ctr"/>
           <a:lstStyle/>
           <a:p>
-            <a:pPr indent="0" marL="0">
-              <a:buNone/>
-            </a:pPr>
-            <a:r>
-              <a:rPr lang="en-US" sz="1200" b="1" spc="300" kern="0" dirty="0">
+            <a:pPr marL="0" indent="0">
+              <a:buNone/>
+            </a:pPr>
+            <a:r>
+              <a:rPr lang="en-US" sz="1200" b="1" kern="0" spc="300" dirty="0">
                 <a:solidFill>
                   <a:srgbClr val="F96167"/>
                 </a:solidFill>
@@ -2728,7 +2438,7 @@
           <a:bodyPr wrap="square" lIns="0" tIns="0" rIns="0" bIns="0" rtlCol="0" anchor="ctr"/>
           <a:lstStyle/>
           <a:p>
-            <a:pPr indent="0" marL="0">
+            <a:pPr marL="0" indent="0">
               <a:buNone/>
             </a:pPr>
             <a:r>
@@ -2767,7 +2477,7 @@
           <a:bodyPr wrap="square" lIns="0" tIns="0" rIns="0" bIns="0" rtlCol="0" anchor="ctr"/>
           <a:lstStyle/>
           <a:p>
-            <a:pPr indent="0" marL="0">
+            <a:pPr marL="0" indent="0">
               <a:buNone/>
             </a:pPr>
             <a:r>
@@ -2804,198 +2514,17 @@
           </a:solidFill>
           <a:ln/>
         </p:spPr>
+        <p:txBody>
+          <a:bodyPr/>
+          <a:lstStyle/>
+          <a:p>
+            <a:endParaRPr lang="en-VN"/>
+          </a:p>
+        </p:txBody>
       </p:sp>
       <p:pic>
         <p:nvPicPr>
-          <p:cNvPr id="6" name="Image 0" descr="/private/tmp/claude-501/-Users-wanbi-Code-oss-projects-viettyping/819a7611-2cb6-438f-ae7c-0ad07e99bd3f/scratchpad/slides/icons/comments_white.png">    </p:cNvPr>
-          <p:cNvPicPr>
-            <a:picLocks noChangeAspect="1"/>
-          </p:cNvPicPr>
-          <p:nvPr/>
-        </p:nvPicPr>
-        <p:blipFill>
-          <a:blip r:embed="rId1"/>
-          <a:stretch>
-            <a:fillRect/>
-          </a:stretch>
-        </p:blipFill>
-        <p:spPr>
-          <a:xfrm>
-            <a:off x="1519276" y="2807208"/>
-            <a:ext cx="649224" cy="649224"/>
-          </a:xfrm>
-          <a:prstGeom prst="rect">
-            <a:avLst/>
-          </a:prstGeom>
-        </p:spPr>
-      </p:pic>
-      <p:sp>
-        <p:nvSpPr>
-          <p:cNvPr id="7" name="Text 4"/>
-          <p:cNvSpPr/>
-          <p:nvPr/>
-        </p:nvSpPr>
-        <p:spPr>
-          <a:xfrm>
-            <a:off x="540868" y="3822192"/>
-            <a:ext cx="2606040" cy="411480"/>
-          </a:xfrm>
-          <a:prstGeom prst="rect">
-            <a:avLst/>
-          </a:prstGeom>
-          <a:noFill/>
-          <a:ln/>
-        </p:spPr>
-        <p:txBody>
-          <a:bodyPr wrap="square" lIns="0" tIns="0" rIns="0" bIns="0" rtlCol="0" anchor="ctr"/>
-          <a:lstStyle/>
-          <a:p>
-            <a:pPr algn="ctr" indent="0" marL="0">
-              <a:buNone/>
-            </a:pPr>
-            <a:r>
-              <a:rPr lang="en-US" sz="1800" b="1" dirty="0">
-                <a:solidFill>
-                  <a:srgbClr val="FFFFFF"/>
-                </a:solidFill>
-                <a:latin typeface="Cambria" pitchFamily="34" charset="0"/>
-                <a:ea typeface="Cambria" pitchFamily="34" charset="-122"/>
-                <a:cs typeface="Cambria" pitchFamily="34" charset="-120"/>
-              </a:rPr>
-              <a:t>Claude</a:t>
-            </a:r>
-            <a:endParaRPr lang="en-US" sz="1800" dirty="0"/>
-          </a:p>
-        </p:txBody>
-      </p:sp>
-      <p:sp>
-        <p:nvSpPr>
-          <p:cNvPr id="8" name="Text 5"/>
-          <p:cNvSpPr/>
-          <p:nvPr/>
-        </p:nvSpPr>
-        <p:spPr>
-          <a:xfrm>
-            <a:off x="540868" y="4224528"/>
-            <a:ext cx="2606040" cy="320040"/>
-          </a:xfrm>
-          <a:prstGeom prst="rect">
-            <a:avLst/>
-          </a:prstGeom>
-          <a:noFill/>
-          <a:ln/>
-        </p:spPr>
-        <p:txBody>
-          <a:bodyPr wrap="square" lIns="0" tIns="0" rIns="0" bIns="0" rtlCol="0" anchor="ctr"/>
-          <a:lstStyle/>
-          <a:p>
-            <a:pPr algn="ctr" indent="0" marL="0">
-              <a:buNone/>
-            </a:pPr>
-            <a:r>
-              <a:rPr lang="en-US" sz="1300" dirty="0">
-                <a:solidFill>
-                  <a:srgbClr val="CADCFC"/>
-                </a:solidFill>
-                <a:latin typeface="Calibri" pitchFamily="34" charset="0"/>
-                <a:ea typeface="Calibri" pitchFamily="34" charset="-122"/>
-                <a:cs typeface="Calibri" pitchFamily="34" charset="-120"/>
-              </a:rPr>
-              <a:t>Brainstorm ý tưởng</a:t>
-            </a:r>
-            <a:endParaRPr lang="en-US" sz="1300" dirty="0"/>
-          </a:p>
-        </p:txBody>
-      </p:sp>
-      <p:sp>
-        <p:nvSpPr>
-          <p:cNvPr id="9" name="Text 6"/>
-          <p:cNvSpPr/>
-          <p:nvPr/>
-        </p:nvSpPr>
-        <p:spPr>
-          <a:xfrm>
-            <a:off x="357988" y="4572000"/>
-            <a:ext cx="2971800" cy="594360"/>
-          </a:xfrm>
-          <a:prstGeom prst="rect">
-            <a:avLst/>
-          </a:prstGeom>
-          <a:noFill/>
-          <a:ln/>
-        </p:spPr>
-        <p:txBody>
-          <a:bodyPr wrap="square" lIns="0" tIns="0" rIns="0" bIns="0" rtlCol="0" anchor="ctr"/>
-          <a:lstStyle/>
-          <a:p>
-            <a:pPr algn="ctr" indent="0" marL="0">
-              <a:lnSpc>
-                <a:spcPts val="1300"/>
-              </a:lnSpc>
-              <a:buNone/>
-            </a:pPr>
-            <a:r>
-              <a:rPr lang="en-US" sz="1050" b="1" dirty="0">
-                <a:solidFill>
-                  <a:srgbClr val="F96167"/>
-                </a:solidFill>
-                <a:latin typeface="Courier New" pitchFamily="34" charset="0"/>
-                <a:ea typeface="Courier New" pitchFamily="34" charset="-122"/>
-                <a:cs typeface="Courier New" pitchFamily="34" charset="-120"/>
-              </a:rPr>
-              <a:t>/brainstorming</a:t>
-            </a:r>
-            <a:endParaRPr lang="en-US" sz="1050" dirty="0"/>
-          </a:p>
-        </p:txBody>
-      </p:sp>
-      <p:pic>
-        <p:nvPicPr>
-          <p:cNvPr id="10" name="Image 1" descr="/private/tmp/claude-501/-Users-wanbi-Code-oss-projects-viettyping/819a7611-2cb6-438f-ae7c-0ad07e99bd3f/scratchpad/slides/icons/arrow_ice.png">    </p:cNvPr>
-          <p:cNvPicPr>
-            <a:picLocks noChangeAspect="1"/>
-          </p:cNvPicPr>
-          <p:nvPr/>
-        </p:nvPicPr>
-        <p:blipFill>
-          <a:blip r:embed="rId2"/>
-          <a:stretch>
-            <a:fillRect/>
-          </a:stretch>
-        </p:blipFill>
-        <p:spPr>
-          <a:xfrm>
-            <a:off x="3078328" y="2948940"/>
-            <a:ext cx="365760" cy="365760"/>
-          </a:xfrm>
-          <a:prstGeom prst="rect">
-            <a:avLst/>
-          </a:prstGeom>
-        </p:spPr>
-      </p:pic>
-      <p:sp>
-        <p:nvSpPr>
-          <p:cNvPr id="11" name="Shape 7"/>
-          <p:cNvSpPr/>
-          <p:nvPr/>
-        </p:nvSpPr>
-        <p:spPr>
-          <a:xfrm>
-            <a:off x="4152748" y="2606040"/>
-            <a:ext cx="1051560" cy="1051560"/>
-          </a:xfrm>
-          <a:prstGeom prst="ellipse">
-            <a:avLst/>
-          </a:prstGeom>
-          <a:solidFill>
-            <a:srgbClr val="F96167"/>
-          </a:solidFill>
-          <a:ln/>
-        </p:spPr>
-      </p:sp>
-      <p:pic>
-        <p:nvPicPr>
-          <p:cNvPr id="12" name="Image 2" descr="/private/tmp/claude-501/-Users-wanbi-Code-oss-projects-viettyping/819a7611-2cb6-438f-ae7c-0ad07e99bd3f/scratchpad/slides/icons/paintbrush_white.png">    </p:cNvPr>
+          <p:cNvPr id="6" name="Image 0" descr="/private/tmp/claude-501/-Users-wanbi-Code-oss-projects-viettyping/819a7611-2cb6-438f-ae7c-0ad07e99bd3f/scratchpad/slides/icons/comments_white.png"/>
           <p:cNvPicPr>
             <a:picLocks noChangeAspect="1"/>
           </p:cNvPicPr>
@@ -3009,7 +2538,7 @@
         </p:blipFill>
         <p:spPr>
           <a:xfrm>
-            <a:off x="4353916" y="2807208"/>
+            <a:off x="1519276" y="2807208"/>
             <a:ext cx="649224" cy="649224"/>
           </a:xfrm>
           <a:prstGeom prst="rect">
@@ -3019,13 +2548,13 @@
       </p:pic>
       <p:sp>
         <p:nvSpPr>
-          <p:cNvPr id="13" name="Text 8"/>
-          <p:cNvSpPr/>
-          <p:nvPr/>
-        </p:nvSpPr>
-        <p:spPr>
-          <a:xfrm>
-            <a:off x="3375508" y="3822192"/>
+          <p:cNvPr id="7" name="Text 4"/>
+          <p:cNvSpPr/>
+          <p:nvPr/>
+        </p:nvSpPr>
+        <p:spPr>
+          <a:xfrm>
+            <a:off x="540868" y="3822192"/>
             <a:ext cx="2606040" cy="411480"/>
           </a:xfrm>
           <a:prstGeom prst="rect">
@@ -3038,7 +2567,7 @@
           <a:bodyPr wrap="square" lIns="0" tIns="0" rIns="0" bIns="0" rtlCol="0" anchor="ctr"/>
           <a:lstStyle/>
           <a:p>
-            <a:pPr algn="ctr" indent="0" marL="0">
+            <a:pPr marL="0" indent="0" algn="ctr">
               <a:buNone/>
             </a:pPr>
             <a:r>
@@ -3050,7 +2579,7 @@
                 <a:ea typeface="Cambria" pitchFamily="34" charset="-122"/>
                 <a:cs typeface="Cambria" pitchFamily="34" charset="-120"/>
               </a:rPr>
-              <a:t>Stitch</a:t>
+              <a:t>Claude</a:t>
             </a:r>
             <a:endParaRPr lang="en-US" sz="1800" dirty="0"/>
           </a:p>
@@ -3058,13 +2587,13 @@
       </p:sp>
       <p:sp>
         <p:nvSpPr>
-          <p:cNvPr id="14" name="Text 9"/>
-          <p:cNvSpPr/>
-          <p:nvPr/>
-        </p:nvSpPr>
-        <p:spPr>
-          <a:xfrm>
-            <a:off x="3375508" y="4224528"/>
+          <p:cNvPr id="8" name="Text 5"/>
+          <p:cNvSpPr/>
+          <p:nvPr/>
+        </p:nvSpPr>
+        <p:spPr>
+          <a:xfrm>
+            <a:off x="540868" y="4224528"/>
             <a:ext cx="2606040" cy="320040"/>
           </a:xfrm>
           <a:prstGeom prst="rect">
@@ -3077,7 +2606,7 @@
           <a:bodyPr wrap="square" lIns="0" tIns="0" rIns="0" bIns="0" rtlCol="0" anchor="ctr"/>
           <a:lstStyle/>
           <a:p>
-            <a:pPr algn="ctr" indent="0" marL="0">
+            <a:pPr marL="0" indent="0" algn="ctr">
               <a:buNone/>
             </a:pPr>
             <a:r>
@@ -3089,15 +2618,57 @@
                 <a:ea typeface="Calibri" pitchFamily="34" charset="-122"/>
                 <a:cs typeface="Calibri" pitchFamily="34" charset="-120"/>
               </a:rPr>
-              <a:t>Thiết kế giao diện</a:t>
+              <a:t>Brainstorm ý tưởng</a:t>
             </a:r>
             <a:endParaRPr lang="en-US" sz="1300" dirty="0"/>
+          </a:p>
+        </p:txBody>
+      </p:sp>
+      <p:sp>
+        <p:nvSpPr>
+          <p:cNvPr id="9" name="Text 6"/>
+          <p:cNvSpPr/>
+          <p:nvPr/>
+        </p:nvSpPr>
+        <p:spPr>
+          <a:xfrm>
+            <a:off x="357988" y="4572000"/>
+            <a:ext cx="2971800" cy="594360"/>
+          </a:xfrm>
+          <a:prstGeom prst="rect">
+            <a:avLst/>
+          </a:prstGeom>
+          <a:noFill/>
+          <a:ln/>
+        </p:spPr>
+        <p:txBody>
+          <a:bodyPr wrap="square" lIns="0" tIns="0" rIns="0" bIns="0" rtlCol="0" anchor="ctr"/>
+          <a:lstStyle/>
+          <a:p>
+            <a:pPr marL="0" indent="0" algn="ctr">
+              <a:lnSpc>
+                <a:spcPts val="1300"/>
+              </a:lnSpc>
+              <a:buNone/>
+            </a:pPr>
+            <a:r>
+              <a:rPr lang="en-US" sz="1050" b="1" dirty="0">
+                <a:solidFill>
+                  <a:srgbClr val="F96167"/>
+                </a:solidFill>
+                <a:latin typeface="Courier New" pitchFamily="34" charset="0"/>
+                <a:ea typeface="Courier New" pitchFamily="34" charset="-122"/>
+                <a:cs typeface="Courier New" pitchFamily="34" charset="-120"/>
+              </a:rPr>
+              <a:t>/brainstorming</a:t>
+            </a:r>
+            <a:endParaRPr lang="en-US" sz="1050" dirty="0"/>
           </a:p>
         </p:txBody>
       </p:sp>
       <p:pic>
         <p:nvPicPr>
-          <p:cNvPr id="15" name="Image 3" descr="/private/tmp/claude-501/-Users-wanbi-Code-oss-projects-viettyping/819a7611-2cb6-438f-ae7c-0ad07e99bd3f/scratchpad/slides/icons/arrow_ice.png">    </p:cNvPr>
+          <p:cNvPr id="10" name="Image 1" descr="/private/tmp/claude-501/-Users-wanbi-Code-oss-projects-viettyping/819a7611-2cb6-438f-ae7c-0ad07e99bd3f/scratchpad/slides/icons/arrow_ice.png"/>
           <p:cNvPicPr>
             <a:picLocks noChangeAspect="1"/>
           </p:cNvPicPr>
@@ -3111,7 +2682,7 @@
         </p:blipFill>
         <p:spPr>
           <a:xfrm>
-            <a:off x="5912968" y="2948940"/>
+            <a:off x="3078328" y="2948940"/>
             <a:ext cx="365760" cy="365760"/>
           </a:xfrm>
           <a:prstGeom prst="rect">
@@ -3121,13 +2692,13 @@
       </p:pic>
       <p:sp>
         <p:nvSpPr>
-          <p:cNvPr id="16" name="Shape 10"/>
-          <p:cNvSpPr/>
-          <p:nvPr/>
-        </p:nvSpPr>
-        <p:spPr>
-          <a:xfrm>
-            <a:off x="6987388" y="2606040"/>
+          <p:cNvPr id="11" name="Shape 7"/>
+          <p:cNvSpPr/>
+          <p:nvPr/>
+        </p:nvSpPr>
+        <p:spPr>
+          <a:xfrm>
+            <a:off x="4152748" y="2606040"/>
             <a:ext cx="1051560" cy="1051560"/>
           </a:xfrm>
           <a:prstGeom prst="ellipse">
@@ -3138,10 +2709,17 @@
           </a:solidFill>
           <a:ln/>
         </p:spPr>
+        <p:txBody>
+          <a:bodyPr/>
+          <a:lstStyle/>
+          <a:p>
+            <a:endParaRPr lang="en-VN"/>
+          </a:p>
+        </p:txBody>
       </p:sp>
       <p:pic>
         <p:nvPicPr>
-          <p:cNvPr id="17" name="Image 4" descr="/private/tmp/claude-501/-Users-wanbi-Code-oss-projects-viettyping/819a7611-2cb6-438f-ae7c-0ad07e99bd3f/scratchpad/slides/icons/code_white.png">    </p:cNvPr>
+          <p:cNvPr id="12" name="Image 2" descr="/private/tmp/claude-501/-Users-wanbi-Code-oss-projects-viettyping/819a7611-2cb6-438f-ae7c-0ad07e99bd3f/scratchpad/slides/icons/paintbrush_white.png"/>
           <p:cNvPicPr>
             <a:picLocks noChangeAspect="1"/>
           </p:cNvPicPr>
@@ -3155,7 +2733,7 @@
         </p:blipFill>
         <p:spPr>
           <a:xfrm>
-            <a:off x="7188556" y="2807208"/>
+            <a:off x="4353916" y="2807208"/>
             <a:ext cx="649224" cy="649224"/>
           </a:xfrm>
           <a:prstGeom prst="rect">
@@ -3165,13 +2743,13 @@
       </p:pic>
       <p:sp>
         <p:nvSpPr>
-          <p:cNvPr id="18" name="Text 11"/>
-          <p:cNvSpPr/>
-          <p:nvPr/>
-        </p:nvSpPr>
-        <p:spPr>
-          <a:xfrm>
-            <a:off x="6210148" y="3822192"/>
+          <p:cNvPr id="13" name="Text 8"/>
+          <p:cNvSpPr/>
+          <p:nvPr/>
+        </p:nvSpPr>
+        <p:spPr>
+          <a:xfrm>
+            <a:off x="3375508" y="3822192"/>
             <a:ext cx="2606040" cy="411480"/>
           </a:xfrm>
           <a:prstGeom prst="rect">
@@ -3184,7 +2762,7 @@
           <a:bodyPr wrap="square" lIns="0" tIns="0" rIns="0" bIns="0" rtlCol="0" anchor="ctr"/>
           <a:lstStyle/>
           <a:p>
-            <a:pPr algn="ctr" indent="0" marL="0">
+            <a:pPr marL="0" indent="0" algn="ctr">
               <a:buNone/>
             </a:pPr>
             <a:r>
@@ -3196,7 +2774,7 @@
                 <a:ea typeface="Cambria" pitchFamily="34" charset="-122"/>
                 <a:cs typeface="Cambria" pitchFamily="34" charset="-120"/>
               </a:rPr>
-              <a:t>AI Studio</a:t>
+              <a:t>Stitch</a:t>
             </a:r>
             <a:endParaRPr lang="en-US" sz="1800" dirty="0"/>
           </a:p>
@@ -3204,13 +2782,13 @@
       </p:sp>
       <p:sp>
         <p:nvSpPr>
-          <p:cNvPr id="19" name="Text 12"/>
-          <p:cNvSpPr/>
-          <p:nvPr/>
-        </p:nvSpPr>
-        <p:spPr>
-          <a:xfrm>
-            <a:off x="6210148" y="4224528"/>
+          <p:cNvPr id="14" name="Text 9"/>
+          <p:cNvSpPr/>
+          <p:nvPr/>
+        </p:nvSpPr>
+        <p:spPr>
+          <a:xfrm>
+            <a:off x="3375508" y="4224528"/>
             <a:ext cx="2606040" cy="320040"/>
           </a:xfrm>
           <a:prstGeom prst="rect">
@@ -3223,7 +2801,7 @@
           <a:bodyPr wrap="square" lIns="0" tIns="0" rIns="0" bIns="0" rtlCol="0" anchor="ctr"/>
           <a:lstStyle/>
           <a:p>
-            <a:pPr algn="ctr" indent="0" marL="0">
+            <a:pPr marL="0" indent="0" algn="ctr">
               <a:buNone/>
             </a:pPr>
             <a:r>
@@ -3235,7 +2813,7 @@
                 <a:ea typeface="Calibri" pitchFamily="34" charset="-122"/>
                 <a:cs typeface="Calibri" pitchFamily="34" charset="-120"/>
               </a:rPr>
-              <a:t>Viết code tự động</a:t>
+              <a:t>Thiết kế giao diện</a:t>
             </a:r>
             <a:endParaRPr lang="en-US" sz="1300" dirty="0"/>
           </a:p>
@@ -3243,7 +2821,58 @@
       </p:sp>
       <p:pic>
         <p:nvPicPr>
-          <p:cNvPr id="20" name="Image 5" descr="/private/tmp/claude-501/-Users-wanbi-Code-oss-projects-viettyping/819a7611-2cb6-438f-ae7c-0ad07e99bd3f/scratchpad/slides/icons/arrow_ice.png">    </p:cNvPr>
+          <p:cNvPr id="15" name="Image 3" descr="/private/tmp/claude-501/-Users-wanbi-Code-oss-projects-viettyping/819a7611-2cb6-438f-ae7c-0ad07e99bd3f/scratchpad/slides/icons/arrow_ice.png"/>
+          <p:cNvPicPr>
+            <a:picLocks noChangeAspect="1"/>
+          </p:cNvPicPr>
+          <p:nvPr/>
+        </p:nvPicPr>
+        <p:blipFill>
+          <a:blip r:embed="rId4"/>
+          <a:stretch>
+            <a:fillRect/>
+          </a:stretch>
+        </p:blipFill>
+        <p:spPr>
+          <a:xfrm>
+            <a:off x="5912968" y="2948940"/>
+            <a:ext cx="365760" cy="365760"/>
+          </a:xfrm>
+          <a:prstGeom prst="rect">
+            <a:avLst/>
+          </a:prstGeom>
+        </p:spPr>
+      </p:pic>
+      <p:sp>
+        <p:nvSpPr>
+          <p:cNvPr id="16" name="Shape 10"/>
+          <p:cNvSpPr/>
+          <p:nvPr/>
+        </p:nvSpPr>
+        <p:spPr>
+          <a:xfrm>
+            <a:off x="6987388" y="2606040"/>
+            <a:ext cx="1051560" cy="1051560"/>
+          </a:xfrm>
+          <a:prstGeom prst="ellipse">
+            <a:avLst/>
+          </a:prstGeom>
+          <a:solidFill>
+            <a:srgbClr val="F96167"/>
+          </a:solidFill>
+          <a:ln/>
+        </p:spPr>
+        <p:txBody>
+          <a:bodyPr/>
+          <a:lstStyle/>
+          <a:p>
+            <a:endParaRPr lang="en-VN"/>
+          </a:p>
+        </p:txBody>
+      </p:sp>
+      <p:pic>
+        <p:nvPicPr>
+          <p:cNvPr id="17" name="Image 4" descr="/private/tmp/claude-501/-Users-wanbi-Code-oss-projects-viettyping/819a7611-2cb6-438f-ae7c-0ad07e99bd3f/scratchpad/slides/icons/code_white.png"/>
           <p:cNvPicPr>
             <a:picLocks noChangeAspect="1"/>
           </p:cNvPicPr>
@@ -3257,6 +2886,108 @@
         </p:blipFill>
         <p:spPr>
           <a:xfrm>
+            <a:off x="7188556" y="2807208"/>
+            <a:ext cx="649224" cy="649224"/>
+          </a:xfrm>
+          <a:prstGeom prst="rect">
+            <a:avLst/>
+          </a:prstGeom>
+        </p:spPr>
+      </p:pic>
+      <p:sp>
+        <p:nvSpPr>
+          <p:cNvPr id="18" name="Text 11"/>
+          <p:cNvSpPr/>
+          <p:nvPr/>
+        </p:nvSpPr>
+        <p:spPr>
+          <a:xfrm>
+            <a:off x="6210148" y="3822192"/>
+            <a:ext cx="2606040" cy="411480"/>
+          </a:xfrm>
+          <a:prstGeom prst="rect">
+            <a:avLst/>
+          </a:prstGeom>
+          <a:noFill/>
+          <a:ln/>
+        </p:spPr>
+        <p:txBody>
+          <a:bodyPr wrap="square" lIns="0" tIns="0" rIns="0" bIns="0" rtlCol="0" anchor="ctr"/>
+          <a:lstStyle/>
+          <a:p>
+            <a:pPr marL="0" indent="0" algn="ctr">
+              <a:buNone/>
+            </a:pPr>
+            <a:r>
+              <a:rPr lang="en-US" sz="1800" b="1" dirty="0">
+                <a:solidFill>
+                  <a:srgbClr val="FFFFFF"/>
+                </a:solidFill>
+                <a:latin typeface="Cambria" pitchFamily="34" charset="0"/>
+                <a:ea typeface="Cambria" pitchFamily="34" charset="-122"/>
+                <a:cs typeface="Cambria" pitchFamily="34" charset="-120"/>
+              </a:rPr>
+              <a:t>AI Studio</a:t>
+            </a:r>
+            <a:endParaRPr lang="en-US" sz="1800" dirty="0"/>
+          </a:p>
+        </p:txBody>
+      </p:sp>
+      <p:sp>
+        <p:nvSpPr>
+          <p:cNvPr id="19" name="Text 12"/>
+          <p:cNvSpPr/>
+          <p:nvPr/>
+        </p:nvSpPr>
+        <p:spPr>
+          <a:xfrm>
+            <a:off x="6210148" y="4224528"/>
+            <a:ext cx="2606040" cy="320040"/>
+          </a:xfrm>
+          <a:prstGeom prst="rect">
+            <a:avLst/>
+          </a:prstGeom>
+          <a:noFill/>
+          <a:ln/>
+        </p:spPr>
+        <p:txBody>
+          <a:bodyPr wrap="square" lIns="0" tIns="0" rIns="0" bIns="0" rtlCol="0" anchor="ctr"/>
+          <a:lstStyle/>
+          <a:p>
+            <a:pPr marL="0" indent="0" algn="ctr">
+              <a:buNone/>
+            </a:pPr>
+            <a:r>
+              <a:rPr lang="en-US" sz="1300" dirty="0">
+                <a:solidFill>
+                  <a:srgbClr val="CADCFC"/>
+                </a:solidFill>
+                <a:latin typeface="Calibri" pitchFamily="34" charset="0"/>
+                <a:ea typeface="Calibri" pitchFamily="34" charset="-122"/>
+                <a:cs typeface="Calibri" pitchFamily="34" charset="-120"/>
+              </a:rPr>
+              <a:t>Viết code tự động</a:t>
+            </a:r>
+            <a:endParaRPr lang="en-US" sz="1300" dirty="0"/>
+          </a:p>
+        </p:txBody>
+      </p:sp>
+      <p:pic>
+        <p:nvPicPr>
+          <p:cNvPr id="20" name="Image 5" descr="/private/tmp/claude-501/-Users-wanbi-Code-oss-projects-viettyping/819a7611-2cb6-438f-ae7c-0ad07e99bd3f/scratchpad/slides/icons/arrow_ice.png"/>
+          <p:cNvPicPr>
+            <a:picLocks noChangeAspect="1"/>
+          </p:cNvPicPr>
+          <p:nvPr/>
+        </p:nvPicPr>
+        <p:blipFill>
+          <a:blip r:embed="rId4"/>
+          <a:stretch>
+            <a:fillRect/>
+          </a:stretch>
+        </p:blipFill>
+        <p:spPr>
+          <a:xfrm>
             <a:off x="8747608" y="2948940"/>
             <a:ext cx="365760" cy="365760"/>
           </a:xfrm>
@@ -3284,10 +3015,17 @@
           </a:solidFill>
           <a:ln/>
         </p:spPr>
+        <p:txBody>
+          <a:bodyPr/>
+          <a:lstStyle/>
+          <a:p>
+            <a:endParaRPr lang="en-VN"/>
+          </a:p>
+        </p:txBody>
       </p:sp>
       <p:pic>
         <p:nvPicPr>
-          <p:cNvPr id="22" name="Image 6" descr="/private/tmp/claude-501/-Users-wanbi-Code-oss-projects-viettyping/819a7611-2cb6-438f-ae7c-0ad07e99bd3f/scratchpad/slides/icons/magic_white.png">    </p:cNvPr>
+          <p:cNvPr id="22" name="Image 6" descr="/private/tmp/claude-501/-Users-wanbi-Code-oss-projects-viettyping/819a7611-2cb6-438f-ae7c-0ad07e99bd3f/scratchpad/slides/icons/magic_white.png"/>
           <p:cNvPicPr>
             <a:picLocks noChangeAspect="1"/>
           </p:cNvPicPr>
@@ -3330,7 +3068,7 @@
           <a:bodyPr wrap="square" lIns="0" tIns="0" rIns="0" bIns="0" rtlCol="0" anchor="ctr"/>
           <a:lstStyle/>
           <a:p>
-            <a:pPr algn="ctr" indent="0" marL="0">
+            <a:pPr marL="0" indent="0" algn="ctr">
               <a:buNone/>
             </a:pPr>
             <a:r>
@@ -3369,7 +3107,7 @@
           <a:bodyPr wrap="square" lIns="0" tIns="0" rIns="0" bIns="0" rtlCol="0" anchor="ctr"/>
           <a:lstStyle/>
           <a:p>
-            <a:pPr algn="ctr" indent="0" marL="0">
+            <a:pPr marL="0" indent="0" algn="ctr">
               <a:buNone/>
             </a:pPr>
             <a:r>
@@ -3408,7 +3146,7 @@
           <a:bodyPr wrap="square" lIns="0" tIns="0" rIns="0" bIns="0" rtlCol="0" anchor="ctr"/>
           <a:lstStyle/>
           <a:p>
-            <a:pPr algn="ctr" indent="0" marL="0">
+            <a:pPr marL="0" indent="0" algn="ctr">
               <a:lnSpc>
                 <a:spcPts val="1300"/>
               </a:lnSpc>
@@ -3450,6 +3188,13 @@
           </a:solidFill>
           <a:ln/>
         </p:spPr>
+        <p:txBody>
+          <a:bodyPr/>
+          <a:lstStyle/>
+          <a:p>
+            <a:endParaRPr lang="en-VN"/>
+          </a:p>
+        </p:txBody>
       </p:sp>
       <p:sp>
         <p:nvSpPr>
@@ -3470,10 +3215,17 @@
           </a:solidFill>
           <a:ln/>
         </p:spPr>
+        <p:txBody>
+          <a:bodyPr/>
+          <a:lstStyle/>
+          <a:p>
+            <a:endParaRPr lang="en-VN"/>
+          </a:p>
+        </p:txBody>
       </p:sp>
       <p:pic>
         <p:nvPicPr>
-          <p:cNvPr id="28" name="Image 7" descr="/private/tmp/claude-501/-Users-wanbi-Code-oss-projects-viettyping/819a7611-2cb6-438f-ae7c-0ad07e99bd3f/scratchpad/slides/icons/github_white.png">    </p:cNvPr>
+          <p:cNvPr id="28" name="Image 7" descr="/private/tmp/claude-501/-Users-wanbi-Code-oss-projects-viettyping/819a7611-2cb6-438f-ae7c-0ad07e99bd3f/scratchpad/slides/icons/github_white.png"/>
           <p:cNvPicPr>
             <a:picLocks noChangeAspect="1"/>
           </p:cNvPicPr>
@@ -3516,7 +3268,7 @@
           <a:bodyPr wrap="square" lIns="0" tIns="0" rIns="0" bIns="0" rtlCol="0" anchor="ctr"/>
           <a:lstStyle/>
           <a:p>
-            <a:pPr indent="0" marL="0">
+            <a:pPr marL="0" indent="0">
               <a:buNone/>
             </a:pPr>
             <a:r>
@@ -3530,9 +3282,6 @@
               </a:rPr>
               <a:t>Skill mở nguồn: </a:t>
             </a:r>
-            <a:pPr indent="0" marL="0">
-              <a:buNone/>
-            </a:pPr>
             <a:r>
               <a:rPr lang="en-US" sz="1250" dirty="0">
                 <a:solidFill>
@@ -3544,9 +3293,6 @@
               </a:rPr>
               <a:t>github.com/obra/superpowers</a:t>
             </a:r>
-            <a:pPr indent="0" marL="0">
-              <a:buNone/>
-            </a:pPr>
             <a:r>
               <a:rPr lang="en-US" sz="1250" i="1" dirty="0">
                 <a:solidFill>
@@ -3578,6 +3324,7 @@
         <a:solidFill>
           <a:srgbClr val="1E2761"/>
         </a:solidFill>
+        <a:effectLst/>
       </p:bgPr>
     </p:bg>
     <p:spTree>
@@ -3596,14 +3343,14 @@
       </p:grpSpPr>
       <p:sp>
         <p:nvSpPr>
-          <p:cNvPr id="2" name="Text 0"/>
-          <p:cNvSpPr/>
-          <p:nvPr/>
-        </p:nvSpPr>
-        <p:spPr>
-          <a:xfrm>
-            <a:off x="640080" y="640080"/>
-            <a:ext cx="5486400" cy="320040"/>
+          <p:cNvPr id="3" name="Text 1"/>
+          <p:cNvSpPr/>
+          <p:nvPr/>
+        </p:nvSpPr>
+        <p:spPr>
+          <a:xfrm>
+            <a:off x="640080" y="1005840"/>
+            <a:ext cx="9144000" cy="685800"/>
           </a:xfrm>
           <a:prstGeom prst="rect">
             <a:avLst/>
@@ -3615,135 +3362,96 @@
           <a:bodyPr wrap="square" lIns="0" tIns="0" rIns="0" bIns="0" rtlCol="0" anchor="ctr"/>
           <a:lstStyle/>
           <a:p>
-            <a:pPr indent="0" marL="0">
-              <a:buNone/>
-            </a:pPr>
-            <a:r>
-              <a:rPr lang="en-US" sz="1200" b="1" spc="300" kern="0" dirty="0">
+            <a:pPr marL="0" indent="0">
+              <a:buNone/>
+            </a:pPr>
+            <a:r>
+              <a:rPr lang="en-US" sz="3200" b="1" dirty="0">
+                <a:solidFill>
+                  <a:srgbClr val="FFFFFF"/>
+                </a:solidFill>
+                <a:latin typeface="Cambria" pitchFamily="34" charset="0"/>
+                <a:ea typeface="Cambria" pitchFamily="34" charset="-122"/>
+                <a:cs typeface="Cambria" pitchFamily="34" charset="-120"/>
+              </a:rPr>
+              <a:t>Kỳ vọng rõ ràng</a:t>
+            </a:r>
+            <a:endParaRPr lang="en-US" sz="3200" dirty="0"/>
+          </a:p>
+        </p:txBody>
+      </p:sp>
+      <p:sp>
+        <p:nvSpPr>
+          <p:cNvPr id="4" name="Text 2"/>
+          <p:cNvSpPr/>
+          <p:nvPr/>
+        </p:nvSpPr>
+        <p:spPr>
+          <a:xfrm>
+            <a:off x="502920" y="1783080"/>
+            <a:ext cx="2926080" cy="1737360"/>
+          </a:xfrm>
+          <a:prstGeom prst="rect">
+            <a:avLst/>
+          </a:prstGeom>
+          <a:noFill/>
+          <a:ln/>
+        </p:spPr>
+        <p:txBody>
+          <a:bodyPr wrap="square" lIns="0" tIns="0" rIns="0" bIns="0" rtlCol="0" anchor="ctr"/>
+          <a:lstStyle/>
+          <a:p>
+            <a:pPr marL="0" indent="0">
+              <a:buNone/>
+            </a:pPr>
+            <a:r>
+              <a:rPr lang="en-US" sz="9600" b="1" dirty="0">
                 <a:solidFill>
                   <a:srgbClr val="F96167"/>
+                </a:solidFill>
+                <a:latin typeface="Cambria" pitchFamily="34" charset="0"/>
+                <a:ea typeface="Cambria" pitchFamily="34" charset="-122"/>
+                <a:cs typeface="Cambria" pitchFamily="34" charset="-120"/>
+              </a:rPr>
+              <a:t>60</a:t>
+            </a:r>
+            <a:endParaRPr lang="en-US" sz="9600" dirty="0"/>
+          </a:p>
+        </p:txBody>
+      </p:sp>
+      <p:sp>
+        <p:nvSpPr>
+          <p:cNvPr id="5" name="Text 3"/>
+          <p:cNvSpPr/>
+          <p:nvPr/>
+        </p:nvSpPr>
+        <p:spPr>
+          <a:xfrm>
+            <a:off x="685800" y="3063240"/>
+            <a:ext cx="2377440" cy="457200"/>
+          </a:xfrm>
+          <a:prstGeom prst="rect">
+            <a:avLst/>
+          </a:prstGeom>
+          <a:noFill/>
+          <a:ln/>
+        </p:spPr>
+        <p:txBody>
+          <a:bodyPr wrap="square" lIns="0" tIns="0" rIns="0" bIns="0" rtlCol="0" anchor="ctr"/>
+          <a:lstStyle/>
+          <a:p>
+            <a:pPr marL="0" indent="0">
+              <a:buNone/>
+            </a:pPr>
+            <a:r>
+              <a:rPr lang="en-US" sz="2000" b="1" kern="0" spc="300" dirty="0">
+                <a:solidFill>
+                  <a:srgbClr val="CADCFC"/>
                 </a:solidFill>
                 <a:latin typeface="Calibri" pitchFamily="34" charset="0"/>
                 <a:ea typeface="Calibri" pitchFamily="34" charset="-122"/>
                 <a:cs typeface="Calibri" pitchFamily="34" charset="-120"/>
               </a:rPr>
-              <a:t>KHÁM PHÁ</a:t>
-            </a:r>
-            <a:endParaRPr lang="en-US" sz="1200" dirty="0"/>
-          </a:p>
-        </p:txBody>
-      </p:sp>
-      <p:sp>
-        <p:nvSpPr>
-          <p:cNvPr id="3" name="Text 1"/>
-          <p:cNvSpPr/>
-          <p:nvPr/>
-        </p:nvSpPr>
-        <p:spPr>
-          <a:xfrm>
-            <a:off x="640080" y="1005840"/>
-            <a:ext cx="9144000" cy="685800"/>
-          </a:xfrm>
-          <a:prstGeom prst="rect">
-            <a:avLst/>
-          </a:prstGeom>
-          <a:noFill/>
-          <a:ln/>
-        </p:spPr>
-        <p:txBody>
-          <a:bodyPr wrap="square" lIns="0" tIns="0" rIns="0" bIns="0" rtlCol="0" anchor="ctr"/>
-          <a:lstStyle/>
-          <a:p>
-            <a:pPr indent="0" marL="0">
-              <a:buNone/>
-            </a:pPr>
-            <a:r>
-              <a:rPr lang="en-US" sz="3200" b="1" dirty="0">
-                <a:solidFill>
-                  <a:srgbClr val="FFFFFF"/>
-                </a:solidFill>
-                <a:latin typeface="Cambria" pitchFamily="34" charset="0"/>
-                <a:ea typeface="Cambria" pitchFamily="34" charset="-122"/>
-                <a:cs typeface="Cambria" pitchFamily="34" charset="-120"/>
-              </a:rPr>
-              <a:t>Kỳ vọng rõ ràng</a:t>
-            </a:r>
-            <a:endParaRPr lang="en-US" sz="3200" dirty="0"/>
-          </a:p>
-        </p:txBody>
-      </p:sp>
-      <p:sp>
-        <p:nvSpPr>
-          <p:cNvPr id="4" name="Text 2"/>
-          <p:cNvSpPr/>
-          <p:nvPr/>
-        </p:nvSpPr>
-        <p:spPr>
-          <a:xfrm>
-            <a:off x="502920" y="1783080"/>
-            <a:ext cx="2926080" cy="1737360"/>
-          </a:xfrm>
-          <a:prstGeom prst="rect">
-            <a:avLst/>
-          </a:prstGeom>
-          <a:noFill/>
-          <a:ln/>
-        </p:spPr>
-        <p:txBody>
-          <a:bodyPr wrap="square" lIns="0" tIns="0" rIns="0" bIns="0" rtlCol="0" anchor="ctr"/>
-          <a:lstStyle/>
-          <a:p>
-            <a:pPr indent="0" marL="0">
-              <a:buNone/>
-            </a:pPr>
-            <a:r>
-              <a:rPr lang="en-US" sz="9600" b="1" dirty="0">
-                <a:solidFill>
-                  <a:srgbClr val="F96167"/>
-                </a:solidFill>
-                <a:latin typeface="Cambria" pitchFamily="34" charset="0"/>
-                <a:ea typeface="Cambria" pitchFamily="34" charset="-122"/>
-                <a:cs typeface="Cambria" pitchFamily="34" charset="-120"/>
-              </a:rPr>
-              <a:t>60</a:t>
-            </a:r>
-            <a:endParaRPr lang="en-US" sz="9600" dirty="0"/>
-          </a:p>
-        </p:txBody>
-      </p:sp>
-      <p:sp>
-        <p:nvSpPr>
-          <p:cNvPr id="5" name="Text 3"/>
-          <p:cNvSpPr/>
-          <p:nvPr/>
-        </p:nvSpPr>
-        <p:spPr>
-          <a:xfrm>
-            <a:off x="685800" y="3063240"/>
-            <a:ext cx="2377440" cy="457200"/>
-          </a:xfrm>
-          <a:prstGeom prst="rect">
-            <a:avLst/>
-          </a:prstGeom>
-          <a:noFill/>
-          <a:ln/>
-        </p:spPr>
-        <p:txBody>
-          <a:bodyPr wrap="square" lIns="0" tIns="0" rIns="0" bIns="0" rtlCol="0" anchor="ctr"/>
-          <a:lstStyle/>
-          <a:p>
-            <a:pPr indent="0" marL="0">
-              <a:buNone/>
-            </a:pPr>
-            <a:r>
-              <a:rPr lang="en-US" sz="2000" b="1" spc="300" kern="0" dirty="0">
-                <a:solidFill>
-                  <a:srgbClr val="CADCFC"/>
-                </a:solidFill>
-                <a:latin typeface="Calibri" pitchFamily="34" charset="0"/>
-                <a:ea typeface="Calibri" pitchFamily="34" charset="-122"/>
-                <a:cs typeface="Calibri" pitchFamily="34" charset="-120"/>
-              </a:rPr>
               <a:t>PHÚT</a:t>
             </a:r>
             <a:endParaRPr lang="en-US" sz="2000" dirty="0"/>
@@ -3771,7 +3479,7 @@
           <a:bodyPr wrap="square" lIns="0" tIns="0" rIns="0" bIns="0" rtlCol="0" anchor="ctr"/>
           <a:lstStyle/>
           <a:p>
-            <a:pPr indent="0" marL="0">
+            <a:pPr marL="0" indent="0">
               <a:lnSpc>
                 <a:spcPts val="3000"/>
               </a:lnSpc>
@@ -3813,6 +3521,13 @@
           </a:solidFill>
           <a:ln/>
         </p:spPr>
+        <p:txBody>
+          <a:bodyPr/>
+          <a:lstStyle/>
+          <a:p>
+            <a:endParaRPr lang="en-VN"/>
+          </a:p>
+        </p:txBody>
       </p:sp>
       <p:sp>
         <p:nvSpPr>
@@ -3835,7 +3550,7 @@
           <a:bodyPr wrap="square" lIns="0" tIns="0" rIns="0" bIns="0" rtlCol="0" anchor="t"/>
           <a:lstStyle/>
           <a:p>
-            <a:pPr indent="0" marL="0">
+            <a:pPr marL="0" indent="0">
               <a:lnSpc>
                 <a:spcPts val="1900"/>
               </a:lnSpc>
@@ -3855,7 +3570,7 @@
             <a:endParaRPr lang="en-US" sz="1400" dirty="0"/>
           </a:p>
           <a:p>
-            <a:pPr indent="0" marL="0">
+            <a:pPr marL="0" indent="0">
               <a:lnSpc>
                 <a:spcPts val="1900"/>
               </a:lnSpc>
@@ -3897,7 +3612,7 @@
           <a:bodyPr wrap="square" lIns="0" tIns="0" rIns="0" bIns="0" rtlCol="0" anchor="t"/>
           <a:lstStyle/>
           <a:p>
-            <a:pPr indent="0" marL="0">
+            <a:pPr marL="0" indent="0">
               <a:lnSpc>
                 <a:spcPts val="1900"/>
               </a:lnSpc>
@@ -3917,7 +3632,7 @@
             <a:endParaRPr lang="en-US" sz="1400" dirty="0"/>
           </a:p>
           <a:p>
-            <a:pPr indent="0" marL="0">
+            <a:pPr marL="0" indent="0">
               <a:lnSpc>
                 <a:spcPts val="1900"/>
               </a:lnSpc>
@@ -3957,17 +3672,24 @@
           </a:solidFill>
           <a:ln/>
         </p:spPr>
+        <p:txBody>
+          <a:bodyPr/>
+          <a:lstStyle/>
+          <a:p>
+            <a:endParaRPr lang="en-VN"/>
+          </a:p>
+        </p:txBody>
       </p:sp>
       <p:pic>
         <p:nvPicPr>
-          <p:cNvPr id="11" name="Image 0" descr="/private/tmp/claude-501/-Users-wanbi-Code-oss-projects-viettyping/819a7611-2cb6-438f-ae7c-0ad07e99bd3f/scratchpad/slides/icons/rocket_white.png">    </p:cNvPr>
+          <p:cNvPr id="11" name="Image 0" descr="/private/tmp/claude-501/-Users-wanbi-Code-oss-projects-viettyping/819a7611-2cb6-438f-ae7c-0ad07e99bd3f/scratchpad/slides/icons/rocket_white.png"/>
           <p:cNvPicPr>
             <a:picLocks noChangeAspect="1"/>
           </p:cNvPicPr>
           <p:nvPr/>
         </p:nvPicPr>
         <p:blipFill>
-          <a:blip r:embed="rId1"/>
+          <a:blip r:embed="rId3"/>
           <a:stretch>
             <a:fillRect/>
           </a:stretch>
@@ -4003,7 +3725,7 @@
           <a:bodyPr wrap="square" lIns="0" tIns="0" rIns="0" bIns="0" rtlCol="0" anchor="ctr"/>
           <a:lstStyle/>
           <a:p>
-            <a:pPr algn="r" indent="0" marL="0">
+            <a:pPr marL="0" indent="0" algn="r">
               <a:buNone/>
             </a:pPr>
             <a:r>
@@ -4322,4 +4044,319 @@
     </a:ext>
   </a:extLst>
 </a:theme>
+</file>
+
+<file path=ppt/theme/theme2.xml><?xml version="1.0" encoding="utf-8"?>
+<a:theme xmlns:a="http://schemas.openxmlformats.org/drawingml/2006/main" name="Office Theme">
+  <a:themeElements>
+    <a:clrScheme name="Office">
+      <a:dk1>
+        <a:sysClr val="windowText" lastClr="000000"/>
+      </a:dk1>
+      <a:lt1>
+        <a:sysClr val="window" lastClr="FFFFFF"/>
+      </a:lt1>
+      <a:dk2>
+        <a:srgbClr val="0E2841"/>
+      </a:dk2>
+      <a:lt2>
+        <a:srgbClr val="E8E8E8"/>
+      </a:lt2>
+      <a:accent1>
+        <a:srgbClr val="156082"/>
+      </a:accent1>
+      <a:accent2>
+        <a:srgbClr val="E97132"/>
+      </a:accent2>
+      <a:accent3>
+        <a:srgbClr val="196B24"/>
+      </a:accent3>
+      <a:accent4>
+        <a:srgbClr val="0F9ED5"/>
+      </a:accent4>
+      <a:accent5>
+        <a:srgbClr val="A02B93"/>
+      </a:accent5>
+      <a:accent6>
+        <a:srgbClr val="4EA72E"/>
+      </a:accent6>
+      <a:hlink>
+        <a:srgbClr val="467886"/>
+      </a:hlink>
+      <a:folHlink>
+        <a:srgbClr val="96607D"/>
+      </a:folHlink>
+    </a:clrScheme>
+    <a:fontScheme name="Office">
+      <a:majorFont>
+        <a:latin typeface="Aptos Display" panose="02110004020202020204"/>
+        <a:ea typeface=""/>
+        <a:cs typeface=""/>
+        <a:font script="Jpan" typeface="游ゴシック Light"/>
+        <a:font script="Hang" typeface="맑은 고딕"/>
+        <a:font script="Hans" typeface="等线 Light"/>
+        <a:font script="Hant" typeface="新細明體"/>
+        <a:font script="Arab" typeface="Times New Roman"/>
+        <a:font script="Hebr" typeface="Times New Roman"/>
+        <a:font script="Thai" typeface="Angsana New"/>
+        <a:font script="Ethi" typeface="Nyala"/>
+        <a:font script="Beng" typeface="Vrinda"/>
+        <a:font script="Gujr" typeface="Shruti"/>
+        <a:font script="Khmr" typeface="MoolBoran"/>
+        <a:font script="Knda" typeface="Tunga"/>
+        <a:font script="Guru" typeface="Raavi"/>
+        <a:font script="Cans" typeface="Euphemia"/>
+        <a:font script="Cher" typeface="Plantagenet Cherokee"/>
+        <a:font script="Yiii" typeface="Microsoft Yi Baiti"/>
+        <a:font script="Tibt" typeface="Microsoft Himalaya"/>
+        <a:font script="Thaa" typeface="MV Boli"/>
+        <a:font script="Deva" typeface="Mangal"/>
+        <a:font script="Telu" typeface="Gautami"/>
+        <a:font script="Taml" typeface="Latha"/>
+        <a:font script="Syrc" typeface="Estrangelo Edessa"/>
+        <a:font script="Orya" typeface="Kalinga"/>
+        <a:font script="Mlym" typeface="Kartika"/>
+        <a:font script="Laoo" typeface="DokChampa"/>
+        <a:font script="Sinh" typeface="Iskoola Pota"/>
+        <a:font script="Mong" typeface="Mongolian Baiti"/>
+        <a:font script="Viet" typeface="Times New Roman"/>
+        <a:font script="Uigh" typeface="Microsoft Uighur"/>
+        <a:font script="Geor" typeface="Sylfaen"/>
+        <a:font script="Armn" typeface="Arial"/>
+        <a:font script="Bugi" typeface="Leelawadee UI"/>
+        <a:font script="Bopo" typeface="Microsoft JhengHei"/>
+        <a:font script="Java" typeface="Javanese Text"/>
+        <a:font script="Lisu" typeface="Segoe UI"/>
+        <a:font script="Mymr" typeface="Myanmar Text"/>
+        <a:font script="Nkoo" typeface="Ebrima"/>
+        <a:font script="Olck" typeface="Nirmala UI"/>
+        <a:font script="Osma" typeface="Ebrima"/>
+        <a:font script="Phag" typeface="Phagspa"/>
+        <a:font script="Syrn" typeface="Estrangelo Edessa"/>
+        <a:font script="Syrj" typeface="Estrangelo Edessa"/>
+        <a:font script="Syre" typeface="Estrangelo Edessa"/>
+        <a:font script="Sora" typeface="Nirmala UI"/>
+        <a:font script="Tale" typeface="Microsoft Tai Le"/>
+        <a:font script="Talu" typeface="Microsoft New Tai Lue"/>
+        <a:font script="Tfng" typeface="Ebrima"/>
+      </a:majorFont>
+      <a:minorFont>
+        <a:latin typeface="Aptos" panose="02110004020202020204"/>
+        <a:ea typeface=""/>
+        <a:cs typeface=""/>
+        <a:font script="Jpan" typeface="游ゴシック"/>
+        <a:font script="Hang" typeface="맑은 고딕"/>
+        <a:font script="Hans" typeface="等线"/>
+        <a:font script="Hant" typeface="新細明體"/>
+        <a:font script="Arab" typeface="Arial"/>
+        <a:font script="Hebr" typeface="Arial"/>
+        <a:font script="Thai" typeface="Cordia New"/>
+        <a:font script="Ethi" typeface="Nyala"/>
+        <a:font script="Beng" typeface="Vrinda"/>
+        <a:font script="Gujr" typeface="Shruti"/>
+        <a:font script="Khmr" typeface="DaunPenh"/>
+        <a:font script="Knda" typeface="Tunga"/>
+        <a:font script="Guru" typeface="Raavi"/>
+        <a:font script="Cans" typeface="Euphemia"/>
+        <a:font script="Cher" typeface="Plantagenet Cherokee"/>
+        <a:font script="Yiii" typeface="Microsoft Yi Baiti"/>
+        <a:font script="Tibt" typeface="Microsoft Himalaya"/>
+        <a:font script="Thaa" typeface="MV Boli"/>
+        <a:font script="Deva" typeface="Mangal"/>
+        <a:font script="Telu" typeface="Gautami"/>
+        <a:font script="Taml" typeface="Latha"/>
+        <a:font script="Syrc" typeface="Estrangelo Edessa"/>
+        <a:font script="Orya" typeface="Kalinga"/>
+        <a:font script="Mlym" typeface="Kartika"/>
+        <a:font script="Laoo" typeface="DokChampa"/>
+        <a:font script="Sinh" typeface="Iskoola Pota"/>
+        <a:font script="Mong" typeface="Mongolian Baiti"/>
+        <a:font script="Viet" typeface="Arial"/>
+        <a:font script="Uigh" typeface="Microsoft Uighur"/>
+        <a:font script="Geor" typeface="Sylfaen"/>
+        <a:font script="Armn" typeface="Arial"/>
+        <a:font script="Bugi" typeface="Leelawadee UI"/>
+        <a:font script="Bopo" typeface="Microsoft JhengHei"/>
+        <a:font script="Java" typeface="Javanese Text"/>
+        <a:font script="Lisu" typeface="Segoe UI"/>
+        <a:font script="Mymr" typeface="Myanmar Text"/>
+        <a:font script="Nkoo" typeface="Ebrima"/>
+        <a:font script="Olck" typeface="Nirmala UI"/>
+        <a:font script="Osma" typeface="Ebrima"/>
+        <a:font script="Phag" typeface="Phagspa"/>
+        <a:font script="Syrn" typeface="Estrangelo Edessa"/>
+        <a:font script="Syrj" typeface="Estrangelo Edessa"/>
+        <a:font script="Syre" typeface="Estrangelo Edessa"/>
+        <a:font script="Sora" typeface="Nirmala UI"/>
+        <a:font script="Tale" typeface="Microsoft Tai Le"/>
+        <a:font script="Talu" typeface="Microsoft New Tai Lue"/>
+        <a:font script="Tfng" typeface="Ebrima"/>
+      </a:minorFont>
+    </a:fontScheme>
+    <a:fmtScheme name="Office">
+      <a:fillStyleLst>
+        <a:solidFill>
+          <a:schemeClr val="phClr"/>
+        </a:solidFill>
+        <a:gradFill rotWithShape="1">
+          <a:gsLst>
+            <a:gs pos="0">
+              <a:schemeClr val="phClr">
+                <a:lumMod val="110000"/>
+                <a:satMod val="105000"/>
+                <a:tint val="67000"/>
+              </a:schemeClr>
+            </a:gs>
+            <a:gs pos="50000">
+              <a:schemeClr val="phClr">
+                <a:lumMod val="105000"/>
+                <a:satMod val="103000"/>
+                <a:tint val="73000"/>
+              </a:schemeClr>
+            </a:gs>
+            <a:gs pos="100000">
+              <a:schemeClr val="phClr">
+                <a:lumMod val="105000"/>
+                <a:satMod val="109000"/>
+                <a:tint val="81000"/>
+              </a:schemeClr>
+            </a:gs>
+          </a:gsLst>
+          <a:lin ang="5400000" scaled="0"/>
+        </a:gradFill>
+        <a:gradFill rotWithShape="1">
+          <a:gsLst>
+            <a:gs pos="0">
+              <a:schemeClr val="phClr">
+                <a:satMod val="103000"/>
+                <a:lumMod val="102000"/>
+                <a:tint val="94000"/>
+              </a:schemeClr>
+            </a:gs>
+            <a:gs pos="50000">
+              <a:schemeClr val="phClr">
+                <a:satMod val="110000"/>
+                <a:lumMod val="100000"/>
+                <a:shade val="100000"/>
+              </a:schemeClr>
+            </a:gs>
+            <a:gs pos="100000">
+              <a:schemeClr val="phClr">
+                <a:lumMod val="99000"/>
+                <a:satMod val="120000"/>
+                <a:shade val="78000"/>
+              </a:schemeClr>
+            </a:gs>
+          </a:gsLst>
+          <a:lin ang="5400000" scaled="0"/>
+        </a:gradFill>
+      </a:fillStyleLst>
+      <a:lnStyleLst>
+        <a:ln w="12700" cap="flat" cmpd="sng" algn="ctr">
+          <a:solidFill>
+            <a:schemeClr val="phClr"/>
+          </a:solidFill>
+          <a:prstDash val="solid"/>
+          <a:miter lim="800000"/>
+        </a:ln>
+        <a:ln w="19050" cap="flat" cmpd="sng" algn="ctr">
+          <a:solidFill>
+            <a:schemeClr val="phClr"/>
+          </a:solidFill>
+          <a:prstDash val="solid"/>
+          <a:miter lim="800000"/>
+        </a:ln>
+        <a:ln w="25400" cap="flat" cmpd="sng" algn="ctr">
+          <a:solidFill>
+            <a:schemeClr val="phClr"/>
+          </a:solidFill>
+          <a:prstDash val="solid"/>
+          <a:miter lim="800000"/>
+        </a:ln>
+      </a:lnStyleLst>
+      <a:effectStyleLst>
+        <a:effectStyle>
+          <a:effectLst/>
+        </a:effectStyle>
+        <a:effectStyle>
+          <a:effectLst/>
+        </a:effectStyle>
+        <a:effectStyle>
+          <a:effectLst>
+            <a:outerShdw blurRad="57150" dist="19050" dir="5400000" algn="ctr" rotWithShape="0">
+              <a:srgbClr val="000000">
+                <a:alpha val="63000"/>
+              </a:srgbClr>
+            </a:outerShdw>
+          </a:effectLst>
+        </a:effectStyle>
+      </a:effectStyleLst>
+      <a:bgFillStyleLst>
+        <a:solidFill>
+          <a:schemeClr val="phClr"/>
+        </a:solidFill>
+        <a:solidFill>
+          <a:schemeClr val="phClr">
+            <a:tint val="95000"/>
+            <a:satMod val="170000"/>
+          </a:schemeClr>
+        </a:solidFill>
+        <a:gradFill rotWithShape="1">
+          <a:gsLst>
+            <a:gs pos="0">
+              <a:schemeClr val="phClr">
+                <a:tint val="93000"/>
+                <a:satMod val="150000"/>
+                <a:shade val="98000"/>
+                <a:lumMod val="102000"/>
+              </a:schemeClr>
+            </a:gs>
+            <a:gs pos="50000">
+              <a:schemeClr val="phClr">
+                <a:tint val="98000"/>
+                <a:satMod val="130000"/>
+                <a:shade val="90000"/>
+                <a:lumMod val="103000"/>
+              </a:schemeClr>
+            </a:gs>
+            <a:gs pos="100000">
+              <a:schemeClr val="phClr">
+                <a:shade val="63000"/>
+                <a:satMod val="120000"/>
+              </a:schemeClr>
+            </a:gs>
+          </a:gsLst>
+          <a:lin ang="5400000" scaled="0"/>
+        </a:gradFill>
+      </a:bgFillStyleLst>
+    </a:fmtScheme>
+  </a:themeElements>
+  <a:objectDefaults>
+    <a:lnDef>
+      <a:spPr/>
+      <a:bodyPr/>
+      <a:lstStyle/>
+      <a:style>
+        <a:lnRef idx="2">
+          <a:schemeClr val="accent1"/>
+        </a:lnRef>
+        <a:fillRef idx="0">
+          <a:schemeClr val="accent1"/>
+        </a:fillRef>
+        <a:effectRef idx="1">
+          <a:schemeClr val="accent1"/>
+        </a:effectRef>
+        <a:fontRef idx="minor">
+          <a:schemeClr val="tx1"/>
+        </a:fontRef>
+      </a:style>
+    </a:lnDef>
+  </a:objectDefaults>
+  <a:extraClrSchemeLst/>
+  <a:extLst>
+    <a:ext uri="{05A4C25C-085E-4340-85A3-A5531E510DB2}">
+      <thm15:themeFamily xmlns:thm15="http://schemas.microsoft.com/office/thememl/2012/main" name="Office Theme" id="{2E142A2C-CD16-42D6-873A-C26D2A0506FA}" vid="{1BDDFF52-6CD6-40A5-AB3C-68EB2F1E4D0A}"/>
+    </a:ext>
+  </a:extLst>
+</a:theme>
 </file>
</xml_diff>